<commit_message>
chore: polish release wording across app and materials
</commit_message>
<xml_diff>
--- a/presentation/Lead-Trace-pitch-enhanced.pptx
+++ b/presentation/Lead-Trace-pitch-enhanced.pptx
@@ -2,24 +2,24 @@
 <file path=ppt/presentation.xml><?xml version="1.0" encoding="utf-8"?>
 <p:presentation xmlns:p="http://schemas.openxmlformats.org/presentationml/2006/main">
   <p:sldMasterIdLst>
-    <p:sldMasterId xmlns:r="http://schemas.openxmlformats.org/officeDocument/2006/relationships" id="2147483648" r:id="Rc36682fe38c54133"/>
+    <p:sldMasterId xmlns:r="http://schemas.openxmlformats.org/officeDocument/2006/relationships" id="2147483648" r:id="R9ec0e67b19264802"/>
   </p:sldMasterIdLst>
   <p:notesMasterIdLst>
-    <p:notesMasterId xmlns:r="http://schemas.openxmlformats.org/officeDocument/2006/relationships" r:id="R1ab30a478564408e"/>
+    <p:notesMasterId xmlns:r="http://schemas.openxmlformats.org/officeDocument/2006/relationships" r:id="Re46cfd2af96a4d3c"/>
   </p:notesMasterIdLst>
   <p:sldIdLst>
-    <p:sldId xmlns:r="http://schemas.openxmlformats.org/officeDocument/2006/relationships" id="256" r:id="Re142ba9c94c347d0"/>
-    <p:sldId xmlns:r="http://schemas.openxmlformats.org/officeDocument/2006/relationships" id="257" r:id="Rafb4000874e14301"/>
-    <p:sldId xmlns:r="http://schemas.openxmlformats.org/officeDocument/2006/relationships" id="258" r:id="R7d4d2d4baed94c9f"/>
-    <p:sldId xmlns:r="http://schemas.openxmlformats.org/officeDocument/2006/relationships" id="259" r:id="R14836c64487e47d6"/>
-    <p:sldId xmlns:r="http://schemas.openxmlformats.org/officeDocument/2006/relationships" id="260" r:id="R437f5106c19e4770"/>
-    <p:sldId xmlns:r="http://schemas.openxmlformats.org/officeDocument/2006/relationships" id="261" r:id="R950b2d4510e04276"/>
-    <p:sldId xmlns:r="http://schemas.openxmlformats.org/officeDocument/2006/relationships" id="262" r:id="Rf0e0b78f9c924229"/>
-    <p:sldId xmlns:r="http://schemas.openxmlformats.org/officeDocument/2006/relationships" id="263" r:id="R92633dfdd3d84451"/>
-    <p:sldId xmlns:r="http://schemas.openxmlformats.org/officeDocument/2006/relationships" id="264" r:id="R34d13621fcec4c49"/>
-    <p:sldId xmlns:r="http://schemas.openxmlformats.org/officeDocument/2006/relationships" id="265" r:id="R71d42c96c4544311"/>
-    <p:sldId xmlns:r="http://schemas.openxmlformats.org/officeDocument/2006/relationships" id="266" r:id="R70dbd2bda7204a8a"/>
-    <p:sldId xmlns:r="http://schemas.openxmlformats.org/officeDocument/2006/relationships" id="267" r:id="Raa66c55720174164"/>
+    <p:sldId xmlns:r="http://schemas.openxmlformats.org/officeDocument/2006/relationships" id="256" r:id="R332fc9fbe5984690"/>
+    <p:sldId xmlns:r="http://schemas.openxmlformats.org/officeDocument/2006/relationships" id="257" r:id="Rb3341d63c0074c6c"/>
+    <p:sldId xmlns:r="http://schemas.openxmlformats.org/officeDocument/2006/relationships" id="258" r:id="Rfe95722983c249a7"/>
+    <p:sldId xmlns:r="http://schemas.openxmlformats.org/officeDocument/2006/relationships" id="259" r:id="Rad5ef14931e44e14"/>
+    <p:sldId xmlns:r="http://schemas.openxmlformats.org/officeDocument/2006/relationships" id="260" r:id="R27c8f255f8094d06"/>
+    <p:sldId xmlns:r="http://schemas.openxmlformats.org/officeDocument/2006/relationships" id="261" r:id="Rd116bf45dfa64657"/>
+    <p:sldId xmlns:r="http://schemas.openxmlformats.org/officeDocument/2006/relationships" id="262" r:id="Rcba9a35fd5cf4e51"/>
+    <p:sldId xmlns:r="http://schemas.openxmlformats.org/officeDocument/2006/relationships" id="263" r:id="R8c429b2b3830470e"/>
+    <p:sldId xmlns:r="http://schemas.openxmlformats.org/officeDocument/2006/relationships" id="264" r:id="Rf97bc462aee247e5"/>
+    <p:sldId xmlns:r="http://schemas.openxmlformats.org/officeDocument/2006/relationships" id="265" r:id="Rc43c65dff1c44d9d"/>
+    <p:sldId xmlns:r="http://schemas.openxmlformats.org/officeDocument/2006/relationships" id="266" r:id="Ra472090ec4e6483c"/>
+    <p:sldId xmlns:r="http://schemas.openxmlformats.org/officeDocument/2006/relationships" id="267" r:id="Rd77e2271100442bf"/>
   </p:sldIdLst>
   <p:sldSz cx="12192000" cy="6858000"/>
   <p:notesSz cx="6858000" cy="9144000"/>
@@ -1291,7 +1291,7 @@
   </p:cSld>
   <p:clrMap bg1="lt1" tx1="dk1" bg2="lt2" tx2="dk2" accent1="accent1" accent2="accent2" accent3="accent3" accent4="accent4" accent5="accent5" accent6="accent6" hlink="hlink" folHlink="folHlink"/>
   <p:sldLayoutIdLst>
-    <p:sldLayoutId xmlns:r="http://schemas.openxmlformats.org/officeDocument/2006/relationships" id="2147483649" r:id="R53646ed383184e69"/>
+    <p:sldLayoutId xmlns:r="http://schemas.openxmlformats.org/officeDocument/2006/relationships" id="2147483649" r:id="R1d717382dc93430d"/>
   </p:sldLayoutIdLst>
   <p:txStyles>
     <p:titleStyle>
@@ -1842,7 +1842,7 @@
           <p:cNvPr id="6" name="">
             <a:extLst xmlns:a="http://schemas.openxmlformats.org/drawingml/2006/main">
               <a:ext uri="{FF2B5EF4-FFF2-40B4-BE49-F238E27FC236}">
-                <a16:creationId xmlns:a16="http://schemas.microsoft.com/office/drawing/2014/main" id="{99F8E682-2A7C-40E8-9938-F6BCF77D123F}"/>
+                <a16:creationId xmlns:a16="http://schemas.microsoft.com/office/drawing/2014/main" id="{CD4C5A75-0D8A-449C-8FCC-DBC5B70F88C5}"/>
               </a:ext>
             </a:extLst>
           </p:cNvPr>
@@ -1852,7 +1852,7 @@
           <p:nvPr/>
         </p:nvPicPr>
         <p:blipFill>
-          <a:blip xmlns:r="http://schemas.openxmlformats.org/officeDocument/2006/relationships" xmlns:a="http://schemas.openxmlformats.org/drawingml/2006/main" r:embed="R2e7fa74ae99e4f6b"/>
+          <a:blip xmlns:r="http://schemas.openxmlformats.org/officeDocument/2006/relationships" xmlns:a="http://schemas.openxmlformats.org/drawingml/2006/main" r:embed="R797817f2286f41b5"/>
           <a:srcRect xmlns:a="http://schemas.openxmlformats.org/drawingml/2006/main" l="0" t="0" r="0" b="0"/>
           <a:stretch xmlns:a="http://schemas.openxmlformats.org/drawingml/2006/main"/>
         </p:blipFill>
@@ -2977,7 +2977,7 @@
           <p:cNvPr id="5" name="">
             <a:extLst xmlns:a="http://schemas.openxmlformats.org/drawingml/2006/main">
               <a:ext uri="{FF2B5EF4-FFF2-40B4-BE49-F238E27FC236}">
-                <a16:creationId xmlns:a16="http://schemas.microsoft.com/office/drawing/2014/main" id="{162D7CF8-5BC7-4D87-A89F-F4F22E95F6D4}"/>
+                <a16:creationId xmlns:a16="http://schemas.microsoft.com/office/drawing/2014/main" id="{2C46365F-297E-4B39-BCFC-A147752FD189}"/>
               </a:ext>
             </a:extLst>
           </p:cNvPr>
@@ -2987,7 +2987,7 @@
           <p:nvPr/>
         </p:nvPicPr>
         <p:blipFill>
-          <a:blip xmlns:r="http://schemas.openxmlformats.org/officeDocument/2006/relationships" xmlns:a="http://schemas.openxmlformats.org/drawingml/2006/main" r:embed="R46a790d31f224eaf"/>
+          <a:blip xmlns:r="http://schemas.openxmlformats.org/officeDocument/2006/relationships" xmlns:a="http://schemas.openxmlformats.org/drawingml/2006/main" r:embed="R594764bfbc5e4754"/>
           <a:stretch xmlns:a="http://schemas.openxmlformats.org/drawingml/2006/main"/>
         </p:blipFill>
         <p:spPr>
@@ -4599,6 +4599,7 @@
               </a:defRPr>
             </a:defPPr>
             <a:lvl1pPr>
+              <a:buNone/>
               <a:defRPr>
                 <a:solidFill>
                   <a:srgbClr val="173B75"/>
@@ -4606,6 +4607,7 @@
               </a:defRPr>
             </a:lvl1pPr>
             <a:lvl2pPr>
+              <a:buNone/>
               <a:defRPr>
                 <a:solidFill>
                   <a:srgbClr val="173B75"/>
@@ -4613,6 +4615,7 @@
               </a:defRPr>
             </a:lvl2pPr>
             <a:lvl3pPr>
+              <a:buNone/>
               <a:defRPr>
                 <a:solidFill>
                   <a:srgbClr val="173B75"/>
@@ -4620,6 +4623,7 @@
               </a:defRPr>
             </a:lvl3pPr>
             <a:lvl4pPr>
+              <a:buNone/>
               <a:defRPr>
                 <a:solidFill>
                   <a:srgbClr val="173B75"/>
@@ -4627,6 +4631,7 @@
               </a:defRPr>
             </a:lvl4pPr>
             <a:lvl5pPr>
+              <a:buNone/>
               <a:defRPr>
                 <a:solidFill>
                   <a:srgbClr val="173B75"/>
@@ -4634,6 +4639,7 @@
               </a:defRPr>
             </a:lvl5pPr>
             <a:lvl6pPr>
+              <a:buNone/>
               <a:defRPr>
                 <a:solidFill>
                   <a:srgbClr val="173B75"/>
@@ -4641,6 +4647,7 @@
               </a:defRPr>
             </a:lvl6pPr>
             <a:lvl7pPr>
+              <a:buNone/>
               <a:defRPr>
                 <a:solidFill>
                   <a:srgbClr val="173B75"/>
@@ -4648,6 +4655,7 @@
               </a:defRPr>
             </a:lvl7pPr>
             <a:lvl8pPr>
+              <a:buNone/>
               <a:defRPr>
                 <a:solidFill>
                   <a:srgbClr val="173B75"/>
@@ -4655,6 +4663,7 @@
               </a:defRPr>
             </a:lvl8pPr>
             <a:lvl9pPr>
+              <a:buNone/>
               <a:defRPr>
                 <a:solidFill>
                   <a:srgbClr val="173B75"/>
@@ -4728,6 +4737,7 @@
               </a:defRPr>
             </a:defPPr>
             <a:lvl1pPr>
+              <a:buNone/>
               <a:defRPr>
                 <a:solidFill>
                   <a:srgbClr val="173B75"/>
@@ -4735,6 +4745,7 @@
               </a:defRPr>
             </a:lvl1pPr>
             <a:lvl2pPr>
+              <a:buNone/>
               <a:defRPr>
                 <a:solidFill>
                   <a:srgbClr val="173B75"/>
@@ -4742,6 +4753,7 @@
               </a:defRPr>
             </a:lvl2pPr>
             <a:lvl3pPr>
+              <a:buNone/>
               <a:defRPr>
                 <a:solidFill>
                   <a:srgbClr val="173B75"/>
@@ -4749,6 +4761,7 @@
               </a:defRPr>
             </a:lvl3pPr>
             <a:lvl4pPr>
+              <a:buNone/>
               <a:defRPr>
                 <a:solidFill>
                   <a:srgbClr val="173B75"/>
@@ -4756,6 +4769,7 @@
               </a:defRPr>
             </a:lvl4pPr>
             <a:lvl5pPr>
+              <a:buNone/>
               <a:defRPr>
                 <a:solidFill>
                   <a:srgbClr val="173B75"/>
@@ -4763,6 +4777,7 @@
               </a:defRPr>
             </a:lvl5pPr>
             <a:lvl6pPr>
+              <a:buNone/>
               <a:defRPr>
                 <a:solidFill>
                   <a:srgbClr val="173B75"/>
@@ -4770,6 +4785,7 @@
               </a:defRPr>
             </a:lvl6pPr>
             <a:lvl7pPr>
+              <a:buNone/>
               <a:defRPr>
                 <a:solidFill>
                   <a:srgbClr val="173B75"/>
@@ -4777,6 +4793,7 @@
               </a:defRPr>
             </a:lvl7pPr>
             <a:lvl8pPr>
+              <a:buNone/>
               <a:defRPr>
                 <a:solidFill>
                   <a:srgbClr val="173B75"/>
@@ -4784,6 +4801,7 @@
               </a:defRPr>
             </a:lvl8pPr>
             <a:lvl9pPr>
+              <a:buNone/>
               <a:defRPr>
                 <a:solidFill>
                   <a:srgbClr val="173B75"/>
@@ -4905,6 +4923,7 @@
               </a:defRPr>
             </a:defPPr>
             <a:lvl1pPr>
+              <a:buNone/>
               <a:defRPr>
                 <a:solidFill>
                   <a:srgbClr val="1768C7"/>
@@ -4912,6 +4931,7 @@
               </a:defRPr>
             </a:lvl1pPr>
             <a:lvl2pPr>
+              <a:buNone/>
               <a:defRPr>
                 <a:solidFill>
                   <a:srgbClr val="1768C7"/>
@@ -4919,6 +4939,7 @@
               </a:defRPr>
             </a:lvl2pPr>
             <a:lvl3pPr>
+              <a:buNone/>
               <a:defRPr>
                 <a:solidFill>
                   <a:srgbClr val="1768C7"/>
@@ -4926,6 +4947,7 @@
               </a:defRPr>
             </a:lvl3pPr>
             <a:lvl4pPr>
+              <a:buNone/>
               <a:defRPr>
                 <a:solidFill>
                   <a:srgbClr val="1768C7"/>
@@ -4933,6 +4955,7 @@
               </a:defRPr>
             </a:lvl4pPr>
             <a:lvl5pPr>
+              <a:buNone/>
               <a:defRPr>
                 <a:solidFill>
                   <a:srgbClr val="1768C7"/>
@@ -4940,6 +4963,7 @@
               </a:defRPr>
             </a:lvl5pPr>
             <a:lvl6pPr>
+              <a:buNone/>
               <a:defRPr>
                 <a:solidFill>
                   <a:srgbClr val="1768C7"/>
@@ -4947,6 +4971,7 @@
               </a:defRPr>
             </a:lvl6pPr>
             <a:lvl7pPr>
+              <a:buNone/>
               <a:defRPr>
                 <a:solidFill>
                   <a:srgbClr val="1768C7"/>
@@ -4954,6 +4979,7 @@
               </a:defRPr>
             </a:lvl7pPr>
             <a:lvl8pPr>
+              <a:buNone/>
               <a:defRPr>
                 <a:solidFill>
                   <a:srgbClr val="1768C7"/>
@@ -4961,6 +4987,7 @@
               </a:defRPr>
             </a:lvl8pPr>
             <a:lvl9pPr>
+              <a:buNone/>
               <a:defRPr>
                 <a:solidFill>
                   <a:srgbClr val="1768C7"/>
@@ -5034,6 +5061,7 @@
               </a:defRPr>
             </a:defPPr>
             <a:lvl1pPr>
+              <a:buNone/>
               <a:defRPr>
                 <a:solidFill>
                   <a:srgbClr val="173B75"/>
@@ -5041,6 +5069,7 @@
               </a:defRPr>
             </a:lvl1pPr>
             <a:lvl2pPr>
+              <a:buNone/>
               <a:defRPr>
                 <a:solidFill>
                   <a:srgbClr val="173B75"/>
@@ -5048,6 +5077,7 @@
               </a:defRPr>
             </a:lvl2pPr>
             <a:lvl3pPr>
+              <a:buNone/>
               <a:defRPr>
                 <a:solidFill>
                   <a:srgbClr val="173B75"/>
@@ -5055,6 +5085,7 @@
               </a:defRPr>
             </a:lvl3pPr>
             <a:lvl4pPr>
+              <a:buNone/>
               <a:defRPr>
                 <a:solidFill>
                   <a:srgbClr val="173B75"/>
@@ -5062,6 +5093,7 @@
               </a:defRPr>
             </a:lvl4pPr>
             <a:lvl5pPr>
+              <a:buNone/>
               <a:defRPr>
                 <a:solidFill>
                   <a:srgbClr val="173B75"/>
@@ -5069,6 +5101,7 @@
               </a:defRPr>
             </a:lvl5pPr>
             <a:lvl6pPr>
+              <a:buNone/>
               <a:defRPr>
                 <a:solidFill>
                   <a:srgbClr val="173B75"/>
@@ -5076,6 +5109,7 @@
               </a:defRPr>
             </a:lvl6pPr>
             <a:lvl7pPr>
+              <a:buNone/>
               <a:defRPr>
                 <a:solidFill>
                   <a:srgbClr val="173B75"/>
@@ -5083,6 +5117,7 @@
               </a:defRPr>
             </a:lvl7pPr>
             <a:lvl8pPr>
+              <a:buNone/>
               <a:defRPr>
                 <a:solidFill>
                   <a:srgbClr val="173B75"/>
@@ -5090,6 +5125,7 @@
               </a:defRPr>
             </a:lvl8pPr>
             <a:lvl9pPr>
+              <a:buNone/>
               <a:defRPr>
                 <a:solidFill>
                   <a:srgbClr val="173B75"/>
@@ -5221,6 +5257,7 @@
               </a:defRPr>
             </a:defPPr>
             <a:lvl1pPr>
+              <a:buNone/>
               <a:defRPr>
                 <a:solidFill>
                   <a:srgbClr val="1768C7"/>
@@ -5228,6 +5265,7 @@
               </a:defRPr>
             </a:lvl1pPr>
             <a:lvl2pPr>
+              <a:buNone/>
               <a:defRPr>
                 <a:solidFill>
                   <a:srgbClr val="1768C7"/>
@@ -5235,6 +5273,7 @@
               </a:defRPr>
             </a:lvl2pPr>
             <a:lvl3pPr>
+              <a:buNone/>
               <a:defRPr>
                 <a:solidFill>
                   <a:srgbClr val="1768C7"/>
@@ -5242,6 +5281,7 @@
               </a:defRPr>
             </a:lvl3pPr>
             <a:lvl4pPr>
+              <a:buNone/>
               <a:defRPr>
                 <a:solidFill>
                   <a:srgbClr val="1768C7"/>
@@ -5249,6 +5289,7 @@
               </a:defRPr>
             </a:lvl4pPr>
             <a:lvl5pPr>
+              <a:buNone/>
               <a:defRPr>
                 <a:solidFill>
                   <a:srgbClr val="1768C7"/>
@@ -5256,6 +5297,7 @@
               </a:defRPr>
             </a:lvl5pPr>
             <a:lvl6pPr>
+              <a:buNone/>
               <a:defRPr>
                 <a:solidFill>
                   <a:srgbClr val="1768C7"/>
@@ -5263,6 +5305,7 @@
               </a:defRPr>
             </a:lvl6pPr>
             <a:lvl7pPr>
+              <a:buNone/>
               <a:defRPr>
                 <a:solidFill>
                   <a:srgbClr val="1768C7"/>
@@ -5270,6 +5313,7 @@
               </a:defRPr>
             </a:lvl7pPr>
             <a:lvl8pPr>
+              <a:buNone/>
               <a:defRPr>
                 <a:solidFill>
                   <a:srgbClr val="1768C7"/>
@@ -5277,6 +5321,7 @@
               </a:defRPr>
             </a:lvl8pPr>
             <a:lvl9pPr>
+              <a:buNone/>
               <a:defRPr>
                 <a:solidFill>
                   <a:srgbClr val="1768C7"/>
@@ -5680,7 +5725,7 @@
           <p:cNvPr id="3" name="">
             <a:extLst xmlns:a="http://schemas.openxmlformats.org/drawingml/2006/main">
               <a:ext uri="{FF2B5EF4-FFF2-40B4-BE49-F238E27FC236}">
-                <a16:creationId xmlns:a16="http://schemas.microsoft.com/office/drawing/2014/main" id="{F7AA59C8-163B-4623-A6BA-7B74F7895377}"/>
+                <a16:creationId xmlns:a16="http://schemas.microsoft.com/office/drawing/2014/main" id="{179EE5FC-8339-41D5-A399-11D256470E88}"/>
               </a:ext>
             </a:extLst>
           </p:cNvPr>
@@ -5690,7 +5735,7 @@
           <p:nvPr/>
         </p:nvPicPr>
         <p:blipFill>
-          <a:blip xmlns:r="http://schemas.openxmlformats.org/officeDocument/2006/relationships" xmlns:a="http://schemas.openxmlformats.org/drawingml/2006/main" r:embed="R1046b4a977eb46a9"/>
+          <a:blip xmlns:r="http://schemas.openxmlformats.org/officeDocument/2006/relationships" xmlns:a="http://schemas.openxmlformats.org/drawingml/2006/main" r:embed="R9045a33294ae47da"/>
           <a:stretch xmlns:a="http://schemas.openxmlformats.org/drawingml/2006/main"/>
         </p:blipFill>
         <p:spPr>
@@ -5708,7 +5753,7 @@
           <p:cNvPr id="4" name="">
             <a:extLst xmlns:a="http://schemas.openxmlformats.org/drawingml/2006/main">
               <a:ext uri="{FF2B5EF4-FFF2-40B4-BE49-F238E27FC236}">
-                <a16:creationId xmlns:a16="http://schemas.microsoft.com/office/drawing/2014/main" id="{79BE21EE-9B7F-400B-B2E6-CB03344B8480}"/>
+                <a16:creationId xmlns:a16="http://schemas.microsoft.com/office/drawing/2014/main" id="{8A2E10DB-CC77-4D44-81B1-C21B7A431BF0}"/>
               </a:ext>
             </a:extLst>
           </p:cNvPr>
@@ -5718,7 +5763,7 @@
           <p:nvPr/>
         </p:nvPicPr>
         <p:blipFill>
-          <a:blip xmlns:r="http://schemas.openxmlformats.org/officeDocument/2006/relationships" xmlns:a="http://schemas.openxmlformats.org/drawingml/2006/main" r:embed="R91116e12c6714242"/>
+          <a:blip xmlns:r="http://schemas.openxmlformats.org/officeDocument/2006/relationships" xmlns:a="http://schemas.openxmlformats.org/drawingml/2006/main" r:embed="R08ea2c8689b94652"/>
           <a:stretch xmlns:a="http://schemas.openxmlformats.org/drawingml/2006/main"/>
         </p:blipFill>
         <p:spPr>
@@ -6334,6 +6379,7 @@
               </a:defRPr>
             </a:defPPr>
             <a:lvl1pPr>
+              <a:buNone/>
               <a:defRPr>
                 <a:solidFill>
                   <a:srgbClr val="173B75"/>
@@ -6341,6 +6387,7 @@
               </a:defRPr>
             </a:lvl1pPr>
             <a:lvl2pPr>
+              <a:buNone/>
               <a:defRPr>
                 <a:solidFill>
                   <a:srgbClr val="173B75"/>
@@ -6348,6 +6395,7 @@
               </a:defRPr>
             </a:lvl2pPr>
             <a:lvl3pPr>
+              <a:buNone/>
               <a:defRPr>
                 <a:solidFill>
                   <a:srgbClr val="173B75"/>
@@ -6355,6 +6403,7 @@
               </a:defRPr>
             </a:lvl3pPr>
             <a:lvl4pPr>
+              <a:buNone/>
               <a:defRPr>
                 <a:solidFill>
                   <a:srgbClr val="173B75"/>
@@ -6362,6 +6411,7 @@
               </a:defRPr>
             </a:lvl4pPr>
             <a:lvl5pPr>
+              <a:buNone/>
               <a:defRPr>
                 <a:solidFill>
                   <a:srgbClr val="173B75"/>
@@ -6369,6 +6419,7 @@
               </a:defRPr>
             </a:lvl5pPr>
             <a:lvl6pPr>
+              <a:buNone/>
               <a:defRPr>
                 <a:solidFill>
                   <a:srgbClr val="173B75"/>
@@ -6376,6 +6427,7 @@
               </a:defRPr>
             </a:lvl6pPr>
             <a:lvl7pPr>
+              <a:buNone/>
               <a:defRPr>
                 <a:solidFill>
                   <a:srgbClr val="173B75"/>
@@ -6383,6 +6435,7 @@
               </a:defRPr>
             </a:lvl7pPr>
             <a:lvl8pPr>
+              <a:buNone/>
               <a:defRPr>
                 <a:solidFill>
                   <a:srgbClr val="173B75"/>
@@ -6390,6 +6443,7 @@
               </a:defRPr>
             </a:lvl8pPr>
             <a:lvl9pPr>
+              <a:buNone/>
               <a:defRPr>
                 <a:solidFill>
                   <a:srgbClr val="173B75"/>
@@ -6463,6 +6517,7 @@
               </a:defRPr>
             </a:defPPr>
             <a:lvl1pPr>
+              <a:buNone/>
               <a:defRPr>
                 <a:solidFill>
                   <a:srgbClr val="1768C7"/>
@@ -6470,6 +6525,7 @@
               </a:defRPr>
             </a:lvl1pPr>
             <a:lvl2pPr>
+              <a:buNone/>
               <a:defRPr>
                 <a:solidFill>
                   <a:srgbClr val="1768C7"/>
@@ -6477,6 +6533,7 @@
               </a:defRPr>
             </a:lvl2pPr>
             <a:lvl3pPr>
+              <a:buNone/>
               <a:defRPr>
                 <a:solidFill>
                   <a:srgbClr val="1768C7"/>
@@ -6484,6 +6541,7 @@
               </a:defRPr>
             </a:lvl3pPr>
             <a:lvl4pPr>
+              <a:buNone/>
               <a:defRPr>
                 <a:solidFill>
                   <a:srgbClr val="1768C7"/>
@@ -6491,6 +6549,7 @@
               </a:defRPr>
             </a:lvl4pPr>
             <a:lvl5pPr>
+              <a:buNone/>
               <a:defRPr>
                 <a:solidFill>
                   <a:srgbClr val="1768C7"/>
@@ -6498,6 +6557,7 @@
               </a:defRPr>
             </a:lvl5pPr>
             <a:lvl6pPr>
+              <a:buNone/>
               <a:defRPr>
                 <a:solidFill>
                   <a:srgbClr val="1768C7"/>
@@ -6505,6 +6565,7 @@
               </a:defRPr>
             </a:lvl6pPr>
             <a:lvl7pPr>
+              <a:buNone/>
               <a:defRPr>
                 <a:solidFill>
                   <a:srgbClr val="1768C7"/>
@@ -6512,6 +6573,7 @@
               </a:defRPr>
             </a:lvl7pPr>
             <a:lvl8pPr>
+              <a:buNone/>
               <a:defRPr>
                 <a:solidFill>
                   <a:srgbClr val="1768C7"/>
@@ -6519,6 +6581,7 @@
               </a:defRPr>
             </a:lvl8pPr>
             <a:lvl9pPr>
+              <a:buNone/>
               <a:defRPr>
                 <a:solidFill>
                   <a:srgbClr val="1768C7"/>
@@ -6592,6 +6655,7 @@
               </a:defRPr>
             </a:defPPr>
             <a:lvl1pPr>
+              <a:buNone/>
               <a:defRPr>
                 <a:solidFill>
                   <a:srgbClr val="173B75"/>
@@ -6599,6 +6663,7 @@
               </a:defRPr>
             </a:lvl1pPr>
             <a:lvl2pPr>
+              <a:buNone/>
               <a:defRPr>
                 <a:solidFill>
                   <a:srgbClr val="173B75"/>
@@ -6606,6 +6671,7 @@
               </a:defRPr>
             </a:lvl2pPr>
             <a:lvl3pPr>
+              <a:buNone/>
               <a:defRPr>
                 <a:solidFill>
                   <a:srgbClr val="173B75"/>
@@ -6613,6 +6679,7 @@
               </a:defRPr>
             </a:lvl3pPr>
             <a:lvl4pPr>
+              <a:buNone/>
               <a:defRPr>
                 <a:solidFill>
                   <a:srgbClr val="173B75"/>
@@ -6620,6 +6687,7 @@
               </a:defRPr>
             </a:lvl4pPr>
             <a:lvl5pPr>
+              <a:buNone/>
               <a:defRPr>
                 <a:solidFill>
                   <a:srgbClr val="173B75"/>
@@ -6627,6 +6695,7 @@
               </a:defRPr>
             </a:lvl5pPr>
             <a:lvl6pPr>
+              <a:buNone/>
               <a:defRPr>
                 <a:solidFill>
                   <a:srgbClr val="173B75"/>
@@ -6634,6 +6703,7 @@
               </a:defRPr>
             </a:lvl6pPr>
             <a:lvl7pPr>
+              <a:buNone/>
               <a:defRPr>
                 <a:solidFill>
                   <a:srgbClr val="173B75"/>
@@ -6641,6 +6711,7 @@
               </a:defRPr>
             </a:lvl7pPr>
             <a:lvl8pPr>
+              <a:buNone/>
               <a:defRPr>
                 <a:solidFill>
                   <a:srgbClr val="173B75"/>
@@ -6648,6 +6719,7 @@
               </a:defRPr>
             </a:lvl8pPr>
             <a:lvl9pPr>
+              <a:buNone/>
               <a:defRPr>
                 <a:solidFill>
                   <a:srgbClr val="173B75"/>
@@ -6769,6 +6841,7 @@
               </a:defRPr>
             </a:defPPr>
             <a:lvl1pPr>
+              <a:buNone/>
               <a:defRPr>
                 <a:solidFill>
                   <a:srgbClr val="1768C7"/>
@@ -6776,6 +6849,7 @@
               </a:defRPr>
             </a:lvl1pPr>
             <a:lvl2pPr>
+              <a:buNone/>
               <a:defRPr>
                 <a:solidFill>
                   <a:srgbClr val="1768C7"/>
@@ -6783,6 +6857,7 @@
               </a:defRPr>
             </a:lvl2pPr>
             <a:lvl3pPr>
+              <a:buNone/>
               <a:defRPr>
                 <a:solidFill>
                   <a:srgbClr val="1768C7"/>
@@ -6790,6 +6865,7 @@
               </a:defRPr>
             </a:lvl3pPr>
             <a:lvl4pPr>
+              <a:buNone/>
               <a:defRPr>
                 <a:solidFill>
                   <a:srgbClr val="1768C7"/>
@@ -6797,6 +6873,7 @@
               </a:defRPr>
             </a:lvl4pPr>
             <a:lvl5pPr>
+              <a:buNone/>
               <a:defRPr>
                 <a:solidFill>
                   <a:srgbClr val="1768C7"/>
@@ -6804,6 +6881,7 @@
               </a:defRPr>
             </a:lvl5pPr>
             <a:lvl6pPr>
+              <a:buNone/>
               <a:defRPr>
                 <a:solidFill>
                   <a:srgbClr val="1768C7"/>
@@ -6811,6 +6889,7 @@
               </a:defRPr>
             </a:lvl6pPr>
             <a:lvl7pPr>
+              <a:buNone/>
               <a:defRPr>
                 <a:solidFill>
                   <a:srgbClr val="1768C7"/>
@@ -6818,6 +6897,7 @@
               </a:defRPr>
             </a:lvl7pPr>
             <a:lvl8pPr>
+              <a:buNone/>
               <a:defRPr>
                 <a:solidFill>
                   <a:srgbClr val="1768C7"/>
@@ -6825,6 +6905,7 @@
               </a:defRPr>
             </a:lvl8pPr>
             <a:lvl9pPr>
+              <a:buNone/>
               <a:defRPr>
                 <a:solidFill>
                   <a:srgbClr val="1768C7"/>
@@ -6898,6 +6979,7 @@
               </a:defRPr>
             </a:defPPr>
             <a:lvl1pPr>
+              <a:buNone/>
               <a:defRPr>
                 <a:solidFill>
                   <a:srgbClr val="173B75"/>
@@ -6905,6 +6987,7 @@
               </a:defRPr>
             </a:lvl1pPr>
             <a:lvl2pPr>
+              <a:buNone/>
               <a:defRPr>
                 <a:solidFill>
                   <a:srgbClr val="173B75"/>
@@ -6912,6 +6995,7 @@
               </a:defRPr>
             </a:lvl2pPr>
             <a:lvl3pPr>
+              <a:buNone/>
               <a:defRPr>
                 <a:solidFill>
                   <a:srgbClr val="173B75"/>
@@ -6919,6 +7003,7 @@
               </a:defRPr>
             </a:lvl3pPr>
             <a:lvl4pPr>
+              <a:buNone/>
               <a:defRPr>
                 <a:solidFill>
                   <a:srgbClr val="173B75"/>
@@ -6926,6 +7011,7 @@
               </a:defRPr>
             </a:lvl4pPr>
             <a:lvl5pPr>
+              <a:buNone/>
               <a:defRPr>
                 <a:solidFill>
                   <a:srgbClr val="173B75"/>
@@ -6933,6 +7019,7 @@
               </a:defRPr>
             </a:lvl5pPr>
             <a:lvl6pPr>
+              <a:buNone/>
               <a:defRPr>
                 <a:solidFill>
                   <a:srgbClr val="173B75"/>
@@ -6940,6 +7027,7 @@
               </a:defRPr>
             </a:lvl6pPr>
             <a:lvl7pPr>
+              <a:buNone/>
               <a:defRPr>
                 <a:solidFill>
                   <a:srgbClr val="173B75"/>
@@ -6947,6 +7035,7 @@
               </a:defRPr>
             </a:lvl7pPr>
             <a:lvl8pPr>
+              <a:buNone/>
               <a:defRPr>
                 <a:solidFill>
                   <a:srgbClr val="173B75"/>
@@ -6954,6 +7043,7 @@
               </a:defRPr>
             </a:lvl8pPr>
             <a:lvl9pPr>
+              <a:buNone/>
               <a:defRPr>
                 <a:solidFill>
                   <a:srgbClr val="173B75"/>
@@ -7075,6 +7165,7 @@
               </a:defRPr>
             </a:defPPr>
             <a:lvl1pPr>
+              <a:buNone/>
               <a:defRPr>
                 <a:solidFill>
                   <a:srgbClr val="173B75"/>
@@ -7082,6 +7173,7 @@
               </a:defRPr>
             </a:lvl1pPr>
             <a:lvl2pPr>
+              <a:buNone/>
               <a:defRPr>
                 <a:solidFill>
                   <a:srgbClr val="173B75"/>
@@ -7089,6 +7181,7 @@
               </a:defRPr>
             </a:lvl2pPr>
             <a:lvl3pPr>
+              <a:buNone/>
               <a:defRPr>
                 <a:solidFill>
                   <a:srgbClr val="173B75"/>
@@ -7096,6 +7189,7 @@
               </a:defRPr>
             </a:lvl3pPr>
             <a:lvl4pPr>
+              <a:buNone/>
               <a:defRPr>
                 <a:solidFill>
                   <a:srgbClr val="173B75"/>
@@ -7103,6 +7197,7 @@
               </a:defRPr>
             </a:lvl4pPr>
             <a:lvl5pPr>
+              <a:buNone/>
               <a:defRPr>
                 <a:solidFill>
                   <a:srgbClr val="173B75"/>
@@ -7110,6 +7205,7 @@
               </a:defRPr>
             </a:lvl5pPr>
             <a:lvl6pPr>
+              <a:buNone/>
               <a:defRPr>
                 <a:solidFill>
                   <a:srgbClr val="173B75"/>
@@ -7117,6 +7213,7 @@
               </a:defRPr>
             </a:lvl6pPr>
             <a:lvl7pPr>
+              <a:buNone/>
               <a:defRPr>
                 <a:solidFill>
                   <a:srgbClr val="173B75"/>
@@ -7124,6 +7221,7 @@
               </a:defRPr>
             </a:lvl7pPr>
             <a:lvl8pPr>
+              <a:buNone/>
               <a:defRPr>
                 <a:solidFill>
                   <a:srgbClr val="173B75"/>
@@ -7131,6 +7229,7 @@
               </a:defRPr>
             </a:lvl8pPr>
             <a:lvl9pPr>
+              <a:buNone/>
               <a:defRPr>
                 <a:solidFill>
                   <a:srgbClr val="173B75"/>
@@ -7204,6 +7303,7 @@
               </a:defRPr>
             </a:defPPr>
             <a:lvl1pPr>
+              <a:buNone/>
               <a:defRPr>
                 <a:solidFill>
                   <a:srgbClr val="1768C7"/>
@@ -7211,6 +7311,7 @@
               </a:defRPr>
             </a:lvl1pPr>
             <a:lvl2pPr>
+              <a:buNone/>
               <a:defRPr>
                 <a:solidFill>
                   <a:srgbClr val="1768C7"/>
@@ -7218,6 +7319,7 @@
               </a:defRPr>
             </a:lvl2pPr>
             <a:lvl3pPr>
+              <a:buNone/>
               <a:defRPr>
                 <a:solidFill>
                   <a:srgbClr val="1768C7"/>
@@ -7225,6 +7327,7 @@
               </a:defRPr>
             </a:lvl3pPr>
             <a:lvl4pPr>
+              <a:buNone/>
               <a:defRPr>
                 <a:solidFill>
                   <a:srgbClr val="1768C7"/>
@@ -7232,6 +7335,7 @@
               </a:defRPr>
             </a:lvl4pPr>
             <a:lvl5pPr>
+              <a:buNone/>
               <a:defRPr>
                 <a:solidFill>
                   <a:srgbClr val="1768C7"/>
@@ -7239,6 +7343,7 @@
               </a:defRPr>
             </a:lvl5pPr>
             <a:lvl6pPr>
+              <a:buNone/>
               <a:defRPr>
                 <a:solidFill>
                   <a:srgbClr val="1768C7"/>
@@ -7246,6 +7351,7 @@
               </a:defRPr>
             </a:lvl6pPr>
             <a:lvl7pPr>
+              <a:buNone/>
               <a:defRPr>
                 <a:solidFill>
                   <a:srgbClr val="1768C7"/>
@@ -7253,6 +7359,7 @@
               </a:defRPr>
             </a:lvl7pPr>
             <a:lvl8pPr>
+              <a:buNone/>
               <a:defRPr>
                 <a:solidFill>
                   <a:srgbClr val="1768C7"/>
@@ -7260,6 +7367,7 @@
               </a:defRPr>
             </a:lvl8pPr>
             <a:lvl9pPr>
+              <a:buNone/>
               <a:defRPr>
                 <a:solidFill>
                   <a:srgbClr val="1768C7"/>
@@ -7573,7 +7681,7 @@
           <p:cNvPr id="10" name="">
             <a:extLst xmlns:a="http://schemas.openxmlformats.org/drawingml/2006/main">
               <a:ext uri="{FF2B5EF4-FFF2-40B4-BE49-F238E27FC236}">
-                <a16:creationId xmlns:a16="http://schemas.microsoft.com/office/drawing/2014/main" id="{1AAB0C77-8B67-426F-B8E6-FCEF16A63EE1}"/>
+                <a16:creationId xmlns:a16="http://schemas.microsoft.com/office/drawing/2014/main" id="{7249F54F-CB39-4130-A33F-A02DCBF5439A}"/>
               </a:ext>
             </a:extLst>
           </p:cNvPr>
@@ -7583,7 +7691,7 @@
           <p:nvPr/>
         </p:nvPicPr>
         <p:blipFill>
-          <a:blip xmlns:r="http://schemas.openxmlformats.org/officeDocument/2006/relationships" xmlns:a="http://schemas.openxmlformats.org/drawingml/2006/main" r:embed="Rc305b240c50c459b"/>
+          <a:blip xmlns:r="http://schemas.openxmlformats.org/officeDocument/2006/relationships" xmlns:a="http://schemas.openxmlformats.org/drawingml/2006/main" r:embed="Rbcbbbd4bd2e346cc"/>
           <a:srcRect xmlns:a="http://schemas.openxmlformats.org/drawingml/2006/main" l="0" t="0" r="0" b="0"/>
           <a:stretch xmlns:a="http://schemas.openxmlformats.org/drawingml/2006/main"/>
         </p:blipFill>
@@ -7951,6 +8059,7 @@
               </a:defRPr>
             </a:defPPr>
             <a:lvl1pPr>
+              <a:buNone/>
               <a:defRPr sz="2175" b="1">
                 <a:solidFill>
                   <a:srgbClr val="173B75"/>
@@ -7961,6 +8070,7 @@
               </a:defRPr>
             </a:lvl1pPr>
             <a:lvl2pPr>
+              <a:buNone/>
               <a:defRPr sz="2175" b="1">
                 <a:solidFill>
                   <a:srgbClr val="173B75"/>
@@ -7971,6 +8081,7 @@
               </a:defRPr>
             </a:lvl2pPr>
             <a:lvl3pPr>
+              <a:buNone/>
               <a:defRPr sz="2175" b="1">
                 <a:solidFill>
                   <a:srgbClr val="173B75"/>
@@ -7981,6 +8092,7 @@
               </a:defRPr>
             </a:lvl3pPr>
             <a:lvl4pPr>
+              <a:buNone/>
               <a:defRPr sz="2175" b="1">
                 <a:solidFill>
                   <a:srgbClr val="173B75"/>
@@ -7991,6 +8103,7 @@
               </a:defRPr>
             </a:lvl4pPr>
             <a:lvl5pPr>
+              <a:buNone/>
               <a:defRPr sz="2175" b="1">
                 <a:solidFill>
                   <a:srgbClr val="173B75"/>
@@ -8001,6 +8114,7 @@
               </a:defRPr>
             </a:lvl5pPr>
             <a:lvl6pPr>
+              <a:buNone/>
               <a:defRPr sz="2175" b="1">
                 <a:solidFill>
                   <a:srgbClr val="173B75"/>
@@ -8011,6 +8125,7 @@
               </a:defRPr>
             </a:lvl6pPr>
             <a:lvl7pPr>
+              <a:buNone/>
               <a:defRPr sz="2175" b="1">
                 <a:solidFill>
                   <a:srgbClr val="173B75"/>
@@ -8021,6 +8136,7 @@
               </a:defRPr>
             </a:lvl7pPr>
             <a:lvl8pPr>
+              <a:buNone/>
               <a:defRPr sz="2175" b="1">
                 <a:solidFill>
                   <a:srgbClr val="173B75"/>
@@ -8031,6 +8147,7 @@
               </a:defRPr>
             </a:lvl8pPr>
             <a:lvl9pPr>
+              <a:buNone/>
               <a:defRPr sz="2175" b="1">
                 <a:solidFill>
                   <a:srgbClr val="173B75"/>
@@ -8043,6 +8160,7 @@
           </a:lstStyle>
           <a:p xmlns:a="http://schemas.openxmlformats.org/drawingml/2006/main">
             <a:pPr>
+              <a:buNone/>
               <a:defRPr sz="2175" b="1">
                 <a:solidFill>
                   <a:srgbClr val="173B75"/>
@@ -8071,7 +8189,7 @@
           <p:cNvPr id="2" name="">
             <a:extLst xmlns:a="http://schemas.openxmlformats.org/drawingml/2006/main">
               <a:ext uri="{FF2B5EF4-FFF2-40B4-BE49-F238E27FC236}">
-                <a16:creationId xmlns:a16="http://schemas.microsoft.com/office/drawing/2014/main" id="{9EB2DB45-990A-4E83-854F-C6C956B4619D}"/>
+                <a16:creationId xmlns:a16="http://schemas.microsoft.com/office/drawing/2014/main" id="{3F708B57-BD8E-46A8-B3E0-2DB4E27A2CF1}"/>
               </a:ext>
             </a:extLst>
           </p:cNvPr>
@@ -8081,10 +8199,10 @@
           <p:nvPr/>
         </p:nvPicPr>
         <p:blipFill>
-          <a:blip xmlns:r="http://schemas.openxmlformats.org/officeDocument/2006/relationships" xmlns:a="http://schemas.openxmlformats.org/drawingml/2006/main" r:embed="Rf4285cb48bd9418d">
+          <a:blip xmlns:r="http://schemas.openxmlformats.org/officeDocument/2006/relationships" xmlns:a="http://schemas.openxmlformats.org/drawingml/2006/main" r:embed="R7278ab48a33e4ba4">
             <a:extLst>
               <a:ext uri="{96DAC541-7B7A-43D3-8B79-37D633B846F1}">
-                <asvg:svgBlip xmlns:asvg="http://schemas.microsoft.com/office/drawing/2016/SVG/main" r:embed="Redc056869654470e"/>
+                <asvg:svgBlip xmlns:asvg="http://schemas.microsoft.com/office/drawing/2016/SVG/main" r:embed="R5c0e6d95b37a4f45"/>
               </a:ext>
             </a:extLst>
           </a:blip>
@@ -8143,6 +8261,7 @@
               </a:defRPr>
             </a:defPPr>
             <a:lvl1pPr>
+              <a:buNone/>
               <a:defRPr sz="2850" b="1">
                 <a:solidFill>
                   <a:srgbClr val="173B75"/>
@@ -8153,6 +8272,7 @@
               </a:defRPr>
             </a:lvl1pPr>
             <a:lvl2pPr>
+              <a:buNone/>
               <a:defRPr sz="2850" b="1">
                 <a:solidFill>
                   <a:srgbClr val="173B75"/>
@@ -8163,6 +8283,7 @@
               </a:defRPr>
             </a:lvl2pPr>
             <a:lvl3pPr>
+              <a:buNone/>
               <a:defRPr sz="2850" b="1">
                 <a:solidFill>
                   <a:srgbClr val="173B75"/>
@@ -8173,6 +8294,7 @@
               </a:defRPr>
             </a:lvl3pPr>
             <a:lvl4pPr>
+              <a:buNone/>
               <a:defRPr sz="2850" b="1">
                 <a:solidFill>
                   <a:srgbClr val="173B75"/>
@@ -8183,6 +8305,7 @@
               </a:defRPr>
             </a:lvl4pPr>
             <a:lvl5pPr>
+              <a:buNone/>
               <a:defRPr sz="2850" b="1">
                 <a:solidFill>
                   <a:srgbClr val="173B75"/>
@@ -8193,6 +8316,7 @@
               </a:defRPr>
             </a:lvl5pPr>
             <a:lvl6pPr>
+              <a:buNone/>
               <a:defRPr sz="2850" b="1">
                 <a:solidFill>
                   <a:srgbClr val="173B75"/>
@@ -8203,6 +8327,7 @@
               </a:defRPr>
             </a:lvl6pPr>
             <a:lvl7pPr>
+              <a:buNone/>
               <a:defRPr sz="2850" b="1">
                 <a:solidFill>
                   <a:srgbClr val="173B75"/>
@@ -8213,6 +8338,7 @@
               </a:defRPr>
             </a:lvl7pPr>
             <a:lvl8pPr>
+              <a:buNone/>
               <a:defRPr sz="2850" b="1">
                 <a:solidFill>
                   <a:srgbClr val="173B75"/>
@@ -8223,6 +8349,7 @@
               </a:defRPr>
             </a:lvl8pPr>
             <a:lvl9pPr>
+              <a:buNone/>
               <a:defRPr sz="2850" b="1">
                 <a:solidFill>
                   <a:srgbClr val="173B75"/>
@@ -8235,6 +8362,7 @@
           </a:lstStyle>
           <a:p xmlns:a="http://schemas.openxmlformats.org/drawingml/2006/main">
             <a:pPr>
+              <a:buNone/>
               <a:defRPr sz="2850" b="1">
                 <a:solidFill>
                   <a:srgbClr val="173B75"/>
@@ -8301,6 +8429,7 @@
               </a:defRPr>
             </a:defPPr>
             <a:lvl1pPr>
+              <a:buNone/>
               <a:defRPr sz="1575" b="0">
                 <a:solidFill>
                   <a:srgbClr val="607DA3"/>
@@ -8311,6 +8440,7 @@
               </a:defRPr>
             </a:lvl1pPr>
             <a:lvl2pPr>
+              <a:buNone/>
               <a:defRPr sz="1575" b="0">
                 <a:solidFill>
                   <a:srgbClr val="607DA3"/>
@@ -8321,6 +8451,7 @@
               </a:defRPr>
             </a:lvl2pPr>
             <a:lvl3pPr>
+              <a:buNone/>
               <a:defRPr sz="1575" b="0">
                 <a:solidFill>
                   <a:srgbClr val="607DA3"/>
@@ -8331,6 +8462,7 @@
               </a:defRPr>
             </a:lvl3pPr>
             <a:lvl4pPr>
+              <a:buNone/>
               <a:defRPr sz="1575" b="0">
                 <a:solidFill>
                   <a:srgbClr val="607DA3"/>
@@ -8341,6 +8473,7 @@
               </a:defRPr>
             </a:lvl4pPr>
             <a:lvl5pPr>
+              <a:buNone/>
               <a:defRPr sz="1575" b="0">
                 <a:solidFill>
                   <a:srgbClr val="607DA3"/>
@@ -8351,6 +8484,7 @@
               </a:defRPr>
             </a:lvl5pPr>
             <a:lvl6pPr>
+              <a:buNone/>
               <a:defRPr sz="1575" b="0">
                 <a:solidFill>
                   <a:srgbClr val="607DA3"/>
@@ -8361,6 +8495,7 @@
               </a:defRPr>
             </a:lvl6pPr>
             <a:lvl7pPr>
+              <a:buNone/>
               <a:defRPr sz="1575" b="0">
                 <a:solidFill>
                   <a:srgbClr val="607DA3"/>
@@ -8371,6 +8506,7 @@
               </a:defRPr>
             </a:lvl7pPr>
             <a:lvl8pPr>
+              <a:buNone/>
               <a:defRPr sz="1575" b="0">
                 <a:solidFill>
                   <a:srgbClr val="607DA3"/>
@@ -8381,6 +8517,7 @@
               </a:defRPr>
             </a:lvl8pPr>
             <a:lvl9pPr>
+              <a:buNone/>
               <a:defRPr sz="1575" b="0">
                 <a:solidFill>
                   <a:srgbClr val="607DA3"/>
@@ -8393,6 +8530,7 @@
           </a:lstStyle>
           <a:p xmlns:a="http://schemas.openxmlformats.org/drawingml/2006/main">
             <a:pPr>
+              <a:buNone/>
               <a:defRPr sz="1575" b="0">
                 <a:solidFill>
                   <a:srgbClr val="607DA3"/>
@@ -8421,7 +8559,7 @@
           <p:cNvPr id="5" name="Blue process arrow">
             <a:extLst xmlns:a="http://schemas.openxmlformats.org/drawingml/2006/main">
               <a:ext uri="{FF2B5EF4-FFF2-40B4-BE49-F238E27FC236}">
-                <a16:creationId xmlns:a16="http://schemas.microsoft.com/office/drawing/2014/main" id="{4BD4B128-656C-46D3-92D5-91BA497DA5FF}"/>
+                <a16:creationId xmlns:a16="http://schemas.microsoft.com/office/drawing/2014/main" id="{62994324-3843-4D8A-8568-51A798B9956E}"/>
               </a:ext>
             </a:extLst>
           </p:cNvPr>
@@ -8449,7 +8587,7 @@
           <p:cNvPr id="6" name="Blue process arrow">
             <a:extLst xmlns:a="http://schemas.openxmlformats.org/drawingml/2006/main">
               <a:ext uri="{FF2B5EF4-FFF2-40B4-BE49-F238E27FC236}">
-                <a16:creationId xmlns:a16="http://schemas.microsoft.com/office/drawing/2014/main" id="{BBDD0C3A-8978-43D6-9952-95A7131FE30D}"/>
+                <a16:creationId xmlns:a16="http://schemas.microsoft.com/office/drawing/2014/main" id="{444BCB25-56B4-4657-A906-2E6403EF308E}"/>
               </a:ext>
             </a:extLst>
           </p:cNvPr>
@@ -8477,7 +8615,7 @@
           <p:cNvPr id="7" name="Blue process arrow">
             <a:extLst xmlns:a="http://schemas.openxmlformats.org/drawingml/2006/main">
               <a:ext uri="{FF2B5EF4-FFF2-40B4-BE49-F238E27FC236}">
-                <a16:creationId xmlns:a16="http://schemas.microsoft.com/office/drawing/2014/main" id="{9B4AC95B-4D89-4C7B-B224-251B466A91FB}"/>
+                <a16:creationId xmlns:a16="http://schemas.microsoft.com/office/drawing/2014/main" id="{CFB41D16-00B5-4345-9A31-C1872CF2B827}"/>
               </a:ext>
             </a:extLst>
           </p:cNvPr>
@@ -8505,7 +8643,7 @@
           <p:cNvPr id="8" name="Blue process arrow">
             <a:extLst xmlns:a="http://schemas.openxmlformats.org/drawingml/2006/main">
               <a:ext uri="{FF2B5EF4-FFF2-40B4-BE49-F238E27FC236}">
-                <a16:creationId xmlns:a16="http://schemas.microsoft.com/office/drawing/2014/main" id="{EA69BABF-636E-4E12-8F41-AF0497C0555C}"/>
+                <a16:creationId xmlns:a16="http://schemas.microsoft.com/office/drawing/2014/main" id="{5ADE8E08-242B-44F7-B3DE-44939F3943F3}"/>
               </a:ext>
             </a:extLst>
           </p:cNvPr>
@@ -8605,6 +8743,7 @@
               </a:defRPr>
             </a:defPPr>
             <a:lvl1pPr>
+              <a:buNone/>
               <a:defRPr sz="1650" b="1">
                 <a:solidFill>
                   <a:srgbClr val="1768C7"/>
@@ -8615,6 +8754,7 @@
               </a:defRPr>
             </a:lvl1pPr>
             <a:lvl2pPr>
+              <a:buNone/>
               <a:defRPr sz="1650" b="1">
                 <a:solidFill>
                   <a:srgbClr val="1768C7"/>
@@ -8625,6 +8765,7 @@
               </a:defRPr>
             </a:lvl2pPr>
             <a:lvl3pPr>
+              <a:buNone/>
               <a:defRPr sz="1650" b="1">
                 <a:solidFill>
                   <a:srgbClr val="1768C7"/>
@@ -8635,6 +8776,7 @@
               </a:defRPr>
             </a:lvl3pPr>
             <a:lvl4pPr>
+              <a:buNone/>
               <a:defRPr sz="1650" b="1">
                 <a:solidFill>
                   <a:srgbClr val="1768C7"/>
@@ -8645,6 +8787,7 @@
               </a:defRPr>
             </a:lvl4pPr>
             <a:lvl5pPr>
+              <a:buNone/>
               <a:defRPr sz="1650" b="1">
                 <a:solidFill>
                   <a:srgbClr val="1768C7"/>
@@ -8655,6 +8798,7 @@
               </a:defRPr>
             </a:lvl5pPr>
             <a:lvl6pPr>
+              <a:buNone/>
               <a:defRPr sz="1650" b="1">
                 <a:solidFill>
                   <a:srgbClr val="1768C7"/>
@@ -8665,6 +8809,7 @@
               </a:defRPr>
             </a:lvl6pPr>
             <a:lvl7pPr>
+              <a:buNone/>
               <a:defRPr sz="1650" b="1">
                 <a:solidFill>
                   <a:srgbClr val="1768C7"/>
@@ -8675,6 +8820,7 @@
               </a:defRPr>
             </a:lvl7pPr>
             <a:lvl8pPr>
+              <a:buNone/>
               <a:defRPr sz="1650" b="1">
                 <a:solidFill>
                   <a:srgbClr val="1768C7"/>
@@ -8685,6 +8831,7 @@
               </a:defRPr>
             </a:lvl8pPr>
             <a:lvl9pPr>
+              <a:buNone/>
               <a:defRPr sz="1650" b="1">
                 <a:solidFill>
                   <a:srgbClr val="1768C7"/>
@@ -8697,6 +8844,7 @@
           </a:lstStyle>
           <a:p xmlns:a="http://schemas.openxmlformats.org/drawingml/2006/main">
             <a:pPr>
+              <a:buNone/>
               <a:defRPr sz="1650" b="1">
                 <a:solidFill>
                   <a:srgbClr val="1768C7"/>
@@ -8763,6 +8911,7 @@
               </a:defRPr>
             </a:defPPr>
             <a:lvl1pPr>
+              <a:buNone/>
               <a:defRPr sz="1575" b="0">
                 <a:solidFill>
                   <a:srgbClr val="173B75"/>
@@ -8773,6 +8922,7 @@
               </a:defRPr>
             </a:lvl1pPr>
             <a:lvl2pPr>
+              <a:buNone/>
               <a:defRPr sz="1575" b="0">
                 <a:solidFill>
                   <a:srgbClr val="173B75"/>
@@ -8783,6 +8933,7 @@
               </a:defRPr>
             </a:lvl2pPr>
             <a:lvl3pPr>
+              <a:buNone/>
               <a:defRPr sz="1575" b="0">
                 <a:solidFill>
                   <a:srgbClr val="173B75"/>
@@ -8793,6 +8944,7 @@
               </a:defRPr>
             </a:lvl3pPr>
             <a:lvl4pPr>
+              <a:buNone/>
               <a:defRPr sz="1575" b="0">
                 <a:solidFill>
                   <a:srgbClr val="173B75"/>
@@ -8803,6 +8955,7 @@
               </a:defRPr>
             </a:lvl4pPr>
             <a:lvl5pPr>
+              <a:buNone/>
               <a:defRPr sz="1575" b="0">
                 <a:solidFill>
                   <a:srgbClr val="173B75"/>
@@ -8813,6 +8966,7 @@
               </a:defRPr>
             </a:lvl5pPr>
             <a:lvl6pPr>
+              <a:buNone/>
               <a:defRPr sz="1575" b="0">
                 <a:solidFill>
                   <a:srgbClr val="173B75"/>
@@ -8823,6 +8977,7 @@
               </a:defRPr>
             </a:lvl6pPr>
             <a:lvl7pPr>
+              <a:buNone/>
               <a:defRPr sz="1575" b="0">
                 <a:solidFill>
                   <a:srgbClr val="173B75"/>
@@ -8833,6 +8988,7 @@
               </a:defRPr>
             </a:lvl7pPr>
             <a:lvl8pPr>
+              <a:buNone/>
               <a:defRPr sz="1575" b="0">
                 <a:solidFill>
                   <a:srgbClr val="173B75"/>
@@ -8843,6 +8999,7 @@
               </a:defRPr>
             </a:lvl8pPr>
             <a:lvl9pPr>
+              <a:buNone/>
               <a:defRPr sz="1575" b="0">
                 <a:solidFill>
                   <a:srgbClr val="173B75"/>
@@ -8855,6 +9012,7 @@
           </a:lstStyle>
           <a:p xmlns:a="http://schemas.openxmlformats.org/drawingml/2006/main">
             <a:pPr>
+              <a:buNone/>
               <a:defRPr sz="1575" b="0">
                 <a:solidFill>
                   <a:srgbClr val="173B75"/>
@@ -8878,6 +9036,7 @@
           </a:p>
           <a:p xmlns:a="http://schemas.openxmlformats.org/drawingml/2006/main">
             <a:pPr>
+              <a:buNone/>
               <a:defRPr sz="1575" b="0">
                 <a:solidFill>
                   <a:srgbClr val="173B75"/>
@@ -8901,6 +9060,7 @@
           </a:p>
           <a:p xmlns:a="http://schemas.openxmlformats.org/drawingml/2006/main">
             <a:pPr>
+              <a:buNone/>
               <a:defRPr sz="1575" b="0">
                 <a:solidFill>
                   <a:srgbClr val="173B75"/>
@@ -9001,6 +9161,7 @@
               </a:defRPr>
             </a:defPPr>
             <a:lvl1pPr>
+              <a:buNone/>
               <a:defRPr sz="1650" b="1">
                 <a:solidFill>
                   <a:srgbClr val="1768C7"/>
@@ -9011,6 +9172,7 @@
               </a:defRPr>
             </a:lvl1pPr>
             <a:lvl2pPr>
+              <a:buNone/>
               <a:defRPr sz="1650" b="1">
                 <a:solidFill>
                   <a:srgbClr val="1768C7"/>
@@ -9021,6 +9183,7 @@
               </a:defRPr>
             </a:lvl2pPr>
             <a:lvl3pPr>
+              <a:buNone/>
               <a:defRPr sz="1650" b="1">
                 <a:solidFill>
                   <a:srgbClr val="1768C7"/>
@@ -9031,6 +9194,7 @@
               </a:defRPr>
             </a:lvl3pPr>
             <a:lvl4pPr>
+              <a:buNone/>
               <a:defRPr sz="1650" b="1">
                 <a:solidFill>
                   <a:srgbClr val="1768C7"/>
@@ -9041,6 +9205,7 @@
               </a:defRPr>
             </a:lvl4pPr>
             <a:lvl5pPr>
+              <a:buNone/>
               <a:defRPr sz="1650" b="1">
                 <a:solidFill>
                   <a:srgbClr val="1768C7"/>
@@ -9051,6 +9216,7 @@
               </a:defRPr>
             </a:lvl5pPr>
             <a:lvl6pPr>
+              <a:buNone/>
               <a:defRPr sz="1650" b="1">
                 <a:solidFill>
                   <a:srgbClr val="1768C7"/>
@@ -9061,6 +9227,7 @@
               </a:defRPr>
             </a:lvl6pPr>
             <a:lvl7pPr>
+              <a:buNone/>
               <a:defRPr sz="1650" b="1">
                 <a:solidFill>
                   <a:srgbClr val="1768C7"/>
@@ -9071,6 +9238,7 @@
               </a:defRPr>
             </a:lvl7pPr>
             <a:lvl8pPr>
+              <a:buNone/>
               <a:defRPr sz="1650" b="1">
                 <a:solidFill>
                   <a:srgbClr val="1768C7"/>
@@ -9081,6 +9249,7 @@
               </a:defRPr>
             </a:lvl8pPr>
             <a:lvl9pPr>
+              <a:buNone/>
               <a:defRPr sz="1650" b="1">
                 <a:solidFill>
                   <a:srgbClr val="1768C7"/>
@@ -9093,6 +9262,7 @@
           </a:lstStyle>
           <a:p xmlns:a="http://schemas.openxmlformats.org/drawingml/2006/main">
             <a:pPr>
+              <a:buNone/>
               <a:defRPr sz="1650" b="1">
                 <a:solidFill>
                   <a:srgbClr val="1768C7"/>
@@ -9159,6 +9329,7 @@
               </a:defRPr>
             </a:defPPr>
             <a:lvl1pPr>
+              <a:buNone/>
               <a:defRPr sz="1575" b="0">
                 <a:solidFill>
                   <a:srgbClr val="173B75"/>
@@ -9169,6 +9340,7 @@
               </a:defRPr>
             </a:lvl1pPr>
             <a:lvl2pPr>
+              <a:buNone/>
               <a:defRPr sz="1575" b="0">
                 <a:solidFill>
                   <a:srgbClr val="173B75"/>
@@ -9179,6 +9351,7 @@
               </a:defRPr>
             </a:lvl2pPr>
             <a:lvl3pPr>
+              <a:buNone/>
               <a:defRPr sz="1575" b="0">
                 <a:solidFill>
                   <a:srgbClr val="173B75"/>
@@ -9189,6 +9362,7 @@
               </a:defRPr>
             </a:lvl3pPr>
             <a:lvl4pPr>
+              <a:buNone/>
               <a:defRPr sz="1575" b="0">
                 <a:solidFill>
                   <a:srgbClr val="173B75"/>
@@ -9199,6 +9373,7 @@
               </a:defRPr>
             </a:lvl4pPr>
             <a:lvl5pPr>
+              <a:buNone/>
               <a:defRPr sz="1575" b="0">
                 <a:solidFill>
                   <a:srgbClr val="173B75"/>
@@ -9209,6 +9384,7 @@
               </a:defRPr>
             </a:lvl5pPr>
             <a:lvl6pPr>
+              <a:buNone/>
               <a:defRPr sz="1575" b="0">
                 <a:solidFill>
                   <a:srgbClr val="173B75"/>
@@ -9219,6 +9395,7 @@
               </a:defRPr>
             </a:lvl6pPr>
             <a:lvl7pPr>
+              <a:buNone/>
               <a:defRPr sz="1575" b="0">
                 <a:solidFill>
                   <a:srgbClr val="173B75"/>
@@ -9229,6 +9406,7 @@
               </a:defRPr>
             </a:lvl7pPr>
             <a:lvl8pPr>
+              <a:buNone/>
               <a:defRPr sz="1575" b="0">
                 <a:solidFill>
                   <a:srgbClr val="173B75"/>
@@ -9239,6 +9417,7 @@
               </a:defRPr>
             </a:lvl8pPr>
             <a:lvl9pPr>
+              <a:buNone/>
               <a:defRPr sz="1575" b="0">
                 <a:solidFill>
                   <a:srgbClr val="173B75"/>
@@ -9251,6 +9430,7 @@
           </a:lstStyle>
           <a:p xmlns:a="http://schemas.openxmlformats.org/drawingml/2006/main">
             <a:pPr>
+              <a:buNone/>
               <a:defRPr sz="1575" b="0">
                 <a:solidFill>
                   <a:srgbClr val="173B75"/>
@@ -9274,6 +9454,7 @@
           </a:p>
           <a:p xmlns:a="http://schemas.openxmlformats.org/drawingml/2006/main">
             <a:pPr>
+              <a:buNone/>
               <a:defRPr sz="1575" b="0">
                 <a:solidFill>
                   <a:srgbClr val="173B75"/>
@@ -9297,6 +9478,7 @@
           </a:p>
           <a:p xmlns:a="http://schemas.openxmlformats.org/drawingml/2006/main">
             <a:pPr>
+              <a:buNone/>
               <a:defRPr sz="1575" b="0">
                 <a:solidFill>
                   <a:srgbClr val="173B75"/>
@@ -9397,6 +9579,7 @@
               </a:defRPr>
             </a:defPPr>
             <a:lvl1pPr>
+              <a:buNone/>
               <a:defRPr sz="1650" b="1">
                 <a:solidFill>
                   <a:srgbClr val="1768C7"/>
@@ -9407,6 +9590,7 @@
               </a:defRPr>
             </a:lvl1pPr>
             <a:lvl2pPr>
+              <a:buNone/>
               <a:defRPr sz="1650" b="1">
                 <a:solidFill>
                   <a:srgbClr val="1768C7"/>
@@ -9417,6 +9601,7 @@
               </a:defRPr>
             </a:lvl2pPr>
             <a:lvl3pPr>
+              <a:buNone/>
               <a:defRPr sz="1650" b="1">
                 <a:solidFill>
                   <a:srgbClr val="1768C7"/>
@@ -9427,6 +9612,7 @@
               </a:defRPr>
             </a:lvl3pPr>
             <a:lvl4pPr>
+              <a:buNone/>
               <a:defRPr sz="1650" b="1">
                 <a:solidFill>
                   <a:srgbClr val="1768C7"/>
@@ -9437,6 +9623,7 @@
               </a:defRPr>
             </a:lvl4pPr>
             <a:lvl5pPr>
+              <a:buNone/>
               <a:defRPr sz="1650" b="1">
                 <a:solidFill>
                   <a:srgbClr val="1768C7"/>
@@ -9447,6 +9634,7 @@
               </a:defRPr>
             </a:lvl5pPr>
             <a:lvl6pPr>
+              <a:buNone/>
               <a:defRPr sz="1650" b="1">
                 <a:solidFill>
                   <a:srgbClr val="1768C7"/>
@@ -9457,6 +9645,7 @@
               </a:defRPr>
             </a:lvl6pPr>
             <a:lvl7pPr>
+              <a:buNone/>
               <a:defRPr sz="1650" b="1">
                 <a:solidFill>
                   <a:srgbClr val="1768C7"/>
@@ -9467,6 +9656,7 @@
               </a:defRPr>
             </a:lvl7pPr>
             <a:lvl8pPr>
+              <a:buNone/>
               <a:defRPr sz="1650" b="1">
                 <a:solidFill>
                   <a:srgbClr val="1768C7"/>
@@ -9477,6 +9667,7 @@
               </a:defRPr>
             </a:lvl8pPr>
             <a:lvl9pPr>
+              <a:buNone/>
               <a:defRPr sz="1650" b="1">
                 <a:solidFill>
                   <a:srgbClr val="1768C7"/>
@@ -9489,6 +9680,7 @@
           </a:lstStyle>
           <a:p xmlns:a="http://schemas.openxmlformats.org/drawingml/2006/main">
             <a:pPr>
+              <a:buNone/>
               <a:defRPr sz="1650" b="1">
                 <a:solidFill>
                   <a:srgbClr val="1768C7"/>
@@ -9555,6 +9747,7 @@
               </a:defRPr>
             </a:defPPr>
             <a:lvl1pPr>
+              <a:buNone/>
               <a:defRPr sz="1575" b="0">
                 <a:solidFill>
                   <a:srgbClr val="173B75"/>
@@ -9565,6 +9758,7 @@
               </a:defRPr>
             </a:lvl1pPr>
             <a:lvl2pPr>
+              <a:buNone/>
               <a:defRPr sz="1575" b="0">
                 <a:solidFill>
                   <a:srgbClr val="173B75"/>
@@ -9575,6 +9769,7 @@
               </a:defRPr>
             </a:lvl2pPr>
             <a:lvl3pPr>
+              <a:buNone/>
               <a:defRPr sz="1575" b="0">
                 <a:solidFill>
                   <a:srgbClr val="173B75"/>
@@ -9585,6 +9780,7 @@
               </a:defRPr>
             </a:lvl3pPr>
             <a:lvl4pPr>
+              <a:buNone/>
               <a:defRPr sz="1575" b="0">
                 <a:solidFill>
                   <a:srgbClr val="173B75"/>
@@ -9595,6 +9791,7 @@
               </a:defRPr>
             </a:lvl4pPr>
             <a:lvl5pPr>
+              <a:buNone/>
               <a:defRPr sz="1575" b="0">
                 <a:solidFill>
                   <a:srgbClr val="173B75"/>
@@ -9605,6 +9802,7 @@
               </a:defRPr>
             </a:lvl5pPr>
             <a:lvl6pPr>
+              <a:buNone/>
               <a:defRPr sz="1575" b="0">
                 <a:solidFill>
                   <a:srgbClr val="173B75"/>
@@ -9615,6 +9813,7 @@
               </a:defRPr>
             </a:lvl6pPr>
             <a:lvl7pPr>
+              <a:buNone/>
               <a:defRPr sz="1575" b="0">
                 <a:solidFill>
                   <a:srgbClr val="173B75"/>
@@ -9625,6 +9824,7 @@
               </a:defRPr>
             </a:lvl7pPr>
             <a:lvl8pPr>
+              <a:buNone/>
               <a:defRPr sz="1575" b="0">
                 <a:solidFill>
                   <a:srgbClr val="173B75"/>
@@ -9635,6 +9835,7 @@
               </a:defRPr>
             </a:lvl8pPr>
             <a:lvl9pPr>
+              <a:buNone/>
               <a:defRPr sz="1575" b="0">
                 <a:solidFill>
                   <a:srgbClr val="173B75"/>
@@ -9647,6 +9848,7 @@
           </a:lstStyle>
           <a:p xmlns:a="http://schemas.openxmlformats.org/drawingml/2006/main">
             <a:pPr>
+              <a:buNone/>
               <a:defRPr sz="1575" b="0">
                 <a:solidFill>
                   <a:srgbClr val="173B75"/>
@@ -9670,6 +9872,7 @@
           </a:p>
           <a:p xmlns:a="http://schemas.openxmlformats.org/drawingml/2006/main">
             <a:pPr>
+              <a:buNone/>
               <a:defRPr sz="1575" b="0">
                 <a:solidFill>
                   <a:srgbClr val="173B75"/>
@@ -9693,6 +9896,7 @@
           </a:p>
           <a:p xmlns:a="http://schemas.openxmlformats.org/drawingml/2006/main">
             <a:pPr>
+              <a:buNone/>
               <a:defRPr sz="1575" b="0">
                 <a:solidFill>
                   <a:srgbClr val="173B75"/>
@@ -9793,6 +9997,7 @@
               </a:defRPr>
             </a:defPPr>
             <a:lvl1pPr>
+              <a:buNone/>
               <a:defRPr sz="1650" b="1">
                 <a:solidFill>
                   <a:srgbClr val="1768C7"/>
@@ -9803,6 +10008,7 @@
               </a:defRPr>
             </a:lvl1pPr>
             <a:lvl2pPr>
+              <a:buNone/>
               <a:defRPr sz="1650" b="1">
                 <a:solidFill>
                   <a:srgbClr val="1768C7"/>
@@ -9813,6 +10019,7 @@
               </a:defRPr>
             </a:lvl2pPr>
             <a:lvl3pPr>
+              <a:buNone/>
               <a:defRPr sz="1650" b="1">
                 <a:solidFill>
                   <a:srgbClr val="1768C7"/>
@@ -9823,6 +10030,7 @@
               </a:defRPr>
             </a:lvl3pPr>
             <a:lvl4pPr>
+              <a:buNone/>
               <a:defRPr sz="1650" b="1">
                 <a:solidFill>
                   <a:srgbClr val="1768C7"/>
@@ -9833,6 +10041,7 @@
               </a:defRPr>
             </a:lvl4pPr>
             <a:lvl5pPr>
+              <a:buNone/>
               <a:defRPr sz="1650" b="1">
                 <a:solidFill>
                   <a:srgbClr val="1768C7"/>
@@ -9843,6 +10052,7 @@
               </a:defRPr>
             </a:lvl5pPr>
             <a:lvl6pPr>
+              <a:buNone/>
               <a:defRPr sz="1650" b="1">
                 <a:solidFill>
                   <a:srgbClr val="1768C7"/>
@@ -9853,6 +10063,7 @@
               </a:defRPr>
             </a:lvl6pPr>
             <a:lvl7pPr>
+              <a:buNone/>
               <a:defRPr sz="1650" b="1">
                 <a:solidFill>
                   <a:srgbClr val="1768C7"/>
@@ -9863,6 +10074,7 @@
               </a:defRPr>
             </a:lvl7pPr>
             <a:lvl8pPr>
+              <a:buNone/>
               <a:defRPr sz="1650" b="1">
                 <a:solidFill>
                   <a:srgbClr val="1768C7"/>
@@ -9873,6 +10085,7 @@
               </a:defRPr>
             </a:lvl8pPr>
             <a:lvl9pPr>
+              <a:buNone/>
               <a:defRPr sz="1650" b="1">
                 <a:solidFill>
                   <a:srgbClr val="1768C7"/>
@@ -9885,6 +10098,7 @@
           </a:lstStyle>
           <a:p xmlns:a="http://schemas.openxmlformats.org/drawingml/2006/main">
             <a:pPr>
+              <a:buNone/>
               <a:defRPr sz="1650" b="1">
                 <a:solidFill>
                   <a:srgbClr val="1768C7"/>
@@ -9951,6 +10165,7 @@
               </a:defRPr>
             </a:defPPr>
             <a:lvl1pPr>
+              <a:buNone/>
               <a:defRPr sz="1575" b="0">
                 <a:solidFill>
                   <a:srgbClr val="173B75"/>
@@ -9961,6 +10176,7 @@
               </a:defRPr>
             </a:lvl1pPr>
             <a:lvl2pPr>
+              <a:buNone/>
               <a:defRPr sz="1575" b="0">
                 <a:solidFill>
                   <a:srgbClr val="173B75"/>
@@ -9971,6 +10187,7 @@
               </a:defRPr>
             </a:lvl2pPr>
             <a:lvl3pPr>
+              <a:buNone/>
               <a:defRPr sz="1575" b="0">
                 <a:solidFill>
                   <a:srgbClr val="173B75"/>
@@ -9981,6 +10198,7 @@
               </a:defRPr>
             </a:lvl3pPr>
             <a:lvl4pPr>
+              <a:buNone/>
               <a:defRPr sz="1575" b="0">
                 <a:solidFill>
                   <a:srgbClr val="173B75"/>
@@ -9991,6 +10209,7 @@
               </a:defRPr>
             </a:lvl4pPr>
             <a:lvl5pPr>
+              <a:buNone/>
               <a:defRPr sz="1575" b="0">
                 <a:solidFill>
                   <a:srgbClr val="173B75"/>
@@ -10001,6 +10220,7 @@
               </a:defRPr>
             </a:lvl5pPr>
             <a:lvl6pPr>
+              <a:buNone/>
               <a:defRPr sz="1575" b="0">
                 <a:solidFill>
                   <a:srgbClr val="173B75"/>
@@ -10011,6 +10231,7 @@
               </a:defRPr>
             </a:lvl6pPr>
             <a:lvl7pPr>
+              <a:buNone/>
               <a:defRPr sz="1575" b="0">
                 <a:solidFill>
                   <a:srgbClr val="173B75"/>
@@ -10021,6 +10242,7 @@
               </a:defRPr>
             </a:lvl7pPr>
             <a:lvl8pPr>
+              <a:buNone/>
               <a:defRPr sz="1575" b="0">
                 <a:solidFill>
                   <a:srgbClr val="173B75"/>
@@ -10031,6 +10253,7 @@
               </a:defRPr>
             </a:lvl8pPr>
             <a:lvl9pPr>
+              <a:buNone/>
               <a:defRPr sz="1575" b="0">
                 <a:solidFill>
                   <a:srgbClr val="173B75"/>
@@ -10043,6 +10266,7 @@
           </a:lstStyle>
           <a:p xmlns:a="http://schemas.openxmlformats.org/drawingml/2006/main">
             <a:pPr>
+              <a:buNone/>
               <a:defRPr sz="1575" b="0">
                 <a:solidFill>
                   <a:srgbClr val="173B75"/>
@@ -10066,6 +10290,7 @@
           </a:p>
           <a:p xmlns:a="http://schemas.openxmlformats.org/drawingml/2006/main">
             <a:pPr>
+              <a:buNone/>
               <a:defRPr sz="1575" b="0">
                 <a:solidFill>
                   <a:srgbClr val="173B75"/>
@@ -10089,6 +10314,7 @@
           </a:p>
           <a:p xmlns:a="http://schemas.openxmlformats.org/drawingml/2006/main">
             <a:pPr>
+              <a:buNone/>
               <a:defRPr sz="1575" b="0">
                 <a:solidFill>
                   <a:srgbClr val="173B75"/>
@@ -10189,6 +10415,7 @@
               </a:defRPr>
             </a:defPPr>
             <a:lvl1pPr>
+              <a:buNone/>
               <a:defRPr sz="1650" b="1">
                 <a:solidFill>
                   <a:srgbClr val="1768C7"/>
@@ -10199,6 +10426,7 @@
               </a:defRPr>
             </a:lvl1pPr>
             <a:lvl2pPr>
+              <a:buNone/>
               <a:defRPr sz="1650" b="1">
                 <a:solidFill>
                   <a:srgbClr val="1768C7"/>
@@ -10209,6 +10437,7 @@
               </a:defRPr>
             </a:lvl2pPr>
             <a:lvl3pPr>
+              <a:buNone/>
               <a:defRPr sz="1650" b="1">
                 <a:solidFill>
                   <a:srgbClr val="1768C7"/>
@@ -10219,6 +10448,7 @@
               </a:defRPr>
             </a:lvl3pPr>
             <a:lvl4pPr>
+              <a:buNone/>
               <a:defRPr sz="1650" b="1">
                 <a:solidFill>
                   <a:srgbClr val="1768C7"/>
@@ -10229,6 +10459,7 @@
               </a:defRPr>
             </a:lvl4pPr>
             <a:lvl5pPr>
+              <a:buNone/>
               <a:defRPr sz="1650" b="1">
                 <a:solidFill>
                   <a:srgbClr val="1768C7"/>
@@ -10239,6 +10470,7 @@
               </a:defRPr>
             </a:lvl5pPr>
             <a:lvl6pPr>
+              <a:buNone/>
               <a:defRPr sz="1650" b="1">
                 <a:solidFill>
                   <a:srgbClr val="1768C7"/>
@@ -10249,6 +10481,7 @@
               </a:defRPr>
             </a:lvl6pPr>
             <a:lvl7pPr>
+              <a:buNone/>
               <a:defRPr sz="1650" b="1">
                 <a:solidFill>
                   <a:srgbClr val="1768C7"/>
@@ -10259,6 +10492,7 @@
               </a:defRPr>
             </a:lvl7pPr>
             <a:lvl8pPr>
+              <a:buNone/>
               <a:defRPr sz="1650" b="1">
                 <a:solidFill>
                   <a:srgbClr val="1768C7"/>
@@ -10269,6 +10503,7 @@
               </a:defRPr>
             </a:lvl8pPr>
             <a:lvl9pPr>
+              <a:buNone/>
               <a:defRPr sz="1650" b="1">
                 <a:solidFill>
                   <a:srgbClr val="1768C7"/>
@@ -10281,6 +10516,7 @@
           </a:lstStyle>
           <a:p xmlns:a="http://schemas.openxmlformats.org/drawingml/2006/main">
             <a:pPr>
+              <a:buNone/>
               <a:defRPr sz="1650" b="1">
                 <a:solidFill>
                   <a:srgbClr val="1768C7"/>
@@ -10347,6 +10583,7 @@
               </a:defRPr>
             </a:defPPr>
             <a:lvl1pPr>
+              <a:buNone/>
               <a:defRPr sz="1575" b="0">
                 <a:solidFill>
                   <a:srgbClr val="173B75"/>
@@ -10357,6 +10594,7 @@
               </a:defRPr>
             </a:lvl1pPr>
             <a:lvl2pPr>
+              <a:buNone/>
               <a:defRPr sz="1575" b="0">
                 <a:solidFill>
                   <a:srgbClr val="173B75"/>
@@ -10367,6 +10605,7 @@
               </a:defRPr>
             </a:lvl2pPr>
             <a:lvl3pPr>
+              <a:buNone/>
               <a:defRPr sz="1575" b="0">
                 <a:solidFill>
                   <a:srgbClr val="173B75"/>
@@ -10377,6 +10616,7 @@
               </a:defRPr>
             </a:lvl3pPr>
             <a:lvl4pPr>
+              <a:buNone/>
               <a:defRPr sz="1575" b="0">
                 <a:solidFill>
                   <a:srgbClr val="173B75"/>
@@ -10387,6 +10627,7 @@
               </a:defRPr>
             </a:lvl4pPr>
             <a:lvl5pPr>
+              <a:buNone/>
               <a:defRPr sz="1575" b="0">
                 <a:solidFill>
                   <a:srgbClr val="173B75"/>
@@ -10397,6 +10638,7 @@
               </a:defRPr>
             </a:lvl5pPr>
             <a:lvl6pPr>
+              <a:buNone/>
               <a:defRPr sz="1575" b="0">
                 <a:solidFill>
                   <a:srgbClr val="173B75"/>
@@ -10407,6 +10649,7 @@
               </a:defRPr>
             </a:lvl6pPr>
             <a:lvl7pPr>
+              <a:buNone/>
               <a:defRPr sz="1575" b="0">
                 <a:solidFill>
                   <a:srgbClr val="173B75"/>
@@ -10417,6 +10660,7 @@
               </a:defRPr>
             </a:lvl7pPr>
             <a:lvl8pPr>
+              <a:buNone/>
               <a:defRPr sz="1575" b="0">
                 <a:solidFill>
                   <a:srgbClr val="173B75"/>
@@ -10427,6 +10671,7 @@
               </a:defRPr>
             </a:lvl8pPr>
             <a:lvl9pPr>
+              <a:buNone/>
               <a:defRPr sz="1575" b="0">
                 <a:solidFill>
                   <a:srgbClr val="173B75"/>
@@ -10439,6 +10684,7 @@
           </a:lstStyle>
           <a:p xmlns:a="http://schemas.openxmlformats.org/drawingml/2006/main">
             <a:pPr>
+              <a:buNone/>
               <a:defRPr sz="1575" b="0">
                 <a:solidFill>
                   <a:srgbClr val="173B75"/>
@@ -10462,6 +10708,7 @@
           </a:p>
           <a:p xmlns:a="http://schemas.openxmlformats.org/drawingml/2006/main">
             <a:pPr>
+              <a:buNone/>
               <a:defRPr sz="1575" b="0">
                 <a:solidFill>
                   <a:srgbClr val="173B75"/>
@@ -10485,6 +10732,7 @@
           </a:p>
           <a:p xmlns:a="http://schemas.openxmlformats.org/drawingml/2006/main">
             <a:pPr>
+              <a:buNone/>
               <a:defRPr sz="1575" b="0">
                 <a:solidFill>
                   <a:srgbClr val="173B75"/>
@@ -10551,6 +10799,7 @@
               </a:defRPr>
             </a:defPPr>
             <a:lvl1pPr>
+              <a:buNone/>
               <a:defRPr sz="1650" b="1">
                 <a:solidFill>
                   <a:srgbClr val="1768C7"/>
@@ -10561,6 +10810,7 @@
               </a:defRPr>
             </a:lvl1pPr>
             <a:lvl2pPr>
+              <a:buNone/>
               <a:defRPr sz="1650" b="1">
                 <a:solidFill>
                   <a:srgbClr val="1768C7"/>
@@ -10571,6 +10821,7 @@
               </a:defRPr>
             </a:lvl2pPr>
             <a:lvl3pPr>
+              <a:buNone/>
               <a:defRPr sz="1650" b="1">
                 <a:solidFill>
                   <a:srgbClr val="1768C7"/>
@@ -10581,6 +10832,7 @@
               </a:defRPr>
             </a:lvl3pPr>
             <a:lvl4pPr>
+              <a:buNone/>
               <a:defRPr sz="1650" b="1">
                 <a:solidFill>
                   <a:srgbClr val="1768C7"/>
@@ -10591,6 +10843,7 @@
               </a:defRPr>
             </a:lvl4pPr>
             <a:lvl5pPr>
+              <a:buNone/>
               <a:defRPr sz="1650" b="1">
                 <a:solidFill>
                   <a:srgbClr val="1768C7"/>
@@ -10601,6 +10854,7 @@
               </a:defRPr>
             </a:lvl5pPr>
             <a:lvl6pPr>
+              <a:buNone/>
               <a:defRPr sz="1650" b="1">
                 <a:solidFill>
                   <a:srgbClr val="1768C7"/>
@@ -10611,6 +10865,7 @@
               </a:defRPr>
             </a:lvl6pPr>
             <a:lvl7pPr>
+              <a:buNone/>
               <a:defRPr sz="1650" b="1">
                 <a:solidFill>
                   <a:srgbClr val="1768C7"/>
@@ -10621,6 +10876,7 @@
               </a:defRPr>
             </a:lvl7pPr>
             <a:lvl8pPr>
+              <a:buNone/>
               <a:defRPr sz="1650" b="1">
                 <a:solidFill>
                   <a:srgbClr val="1768C7"/>
@@ -10631,6 +10887,7 @@
               </a:defRPr>
             </a:lvl8pPr>
             <a:lvl9pPr>
+              <a:buNone/>
               <a:defRPr sz="1650" b="1">
                 <a:solidFill>
                   <a:srgbClr val="1768C7"/>
@@ -10643,6 +10900,7 @@
           </a:lstStyle>
           <a:p xmlns:a="http://schemas.openxmlformats.org/drawingml/2006/main">
             <a:pPr>
+              <a:buNone/>
               <a:defRPr sz="1650" b="1">
                 <a:solidFill>
                   <a:srgbClr val="1768C7"/>
@@ -10709,6 +10967,7 @@
               </a:defRPr>
             </a:defPPr>
             <a:lvl1pPr>
+              <a:buNone/>
               <a:defRPr sz="1125" b="0">
                 <a:solidFill>
                   <a:srgbClr val="607DA3"/>
@@ -10719,6 +10978,7 @@
               </a:defRPr>
             </a:lvl1pPr>
             <a:lvl2pPr>
+              <a:buNone/>
               <a:defRPr sz="1125" b="0">
                 <a:solidFill>
                   <a:srgbClr val="607DA3"/>
@@ -10729,6 +10989,7 @@
               </a:defRPr>
             </a:lvl2pPr>
             <a:lvl3pPr>
+              <a:buNone/>
               <a:defRPr sz="1125" b="0">
                 <a:solidFill>
                   <a:srgbClr val="607DA3"/>
@@ -10739,6 +11000,7 @@
               </a:defRPr>
             </a:lvl3pPr>
             <a:lvl4pPr>
+              <a:buNone/>
               <a:defRPr sz="1125" b="0">
                 <a:solidFill>
                   <a:srgbClr val="607DA3"/>
@@ -10749,6 +11011,7 @@
               </a:defRPr>
             </a:lvl4pPr>
             <a:lvl5pPr>
+              <a:buNone/>
               <a:defRPr sz="1125" b="0">
                 <a:solidFill>
                   <a:srgbClr val="607DA3"/>
@@ -10759,6 +11022,7 @@
               </a:defRPr>
             </a:lvl5pPr>
             <a:lvl6pPr>
+              <a:buNone/>
               <a:defRPr sz="1125" b="0">
                 <a:solidFill>
                   <a:srgbClr val="607DA3"/>
@@ -10769,6 +11033,7 @@
               </a:defRPr>
             </a:lvl6pPr>
             <a:lvl7pPr>
+              <a:buNone/>
               <a:defRPr sz="1125" b="0">
                 <a:solidFill>
                   <a:srgbClr val="607DA3"/>
@@ -10779,6 +11044,7 @@
               </a:defRPr>
             </a:lvl7pPr>
             <a:lvl8pPr>
+              <a:buNone/>
               <a:defRPr sz="1125" b="0">
                 <a:solidFill>
                   <a:srgbClr val="607DA3"/>
@@ -10789,6 +11055,7 @@
               </a:defRPr>
             </a:lvl8pPr>
             <a:lvl9pPr>
+              <a:buNone/>
               <a:defRPr sz="1125" b="0">
                 <a:solidFill>
                   <a:srgbClr val="607DA3"/>
@@ -10801,6 +11068,7 @@
           </a:lstStyle>
           <a:p xmlns:a="http://schemas.openxmlformats.org/drawingml/2006/main">
             <a:pPr>
+              <a:buNone/>
               <a:defRPr sz="1125" b="0">
                 <a:solidFill>
                   <a:srgbClr val="607DA3"/>
@@ -10916,7 +11184,7 @@
           <p:cNvPr id="10" name="">
             <a:extLst xmlns:a="http://schemas.openxmlformats.org/drawingml/2006/main">
               <a:ext uri="{FF2B5EF4-FFF2-40B4-BE49-F238E27FC236}">
-                <a16:creationId xmlns:a16="http://schemas.microsoft.com/office/drawing/2014/main" id="{4A76E2AB-47D7-4572-84BE-388B9B18AE64}"/>
+                <a16:creationId xmlns:a16="http://schemas.microsoft.com/office/drawing/2014/main" id="{3A96ADCD-9F2B-40C4-9039-C39F1482198C}"/>
               </a:ext>
             </a:extLst>
           </p:cNvPr>
@@ -10926,7 +11194,7 @@
           <p:nvPr/>
         </p:nvPicPr>
         <p:blipFill>
-          <a:blip xmlns:r="http://schemas.openxmlformats.org/officeDocument/2006/relationships" xmlns:a="http://schemas.openxmlformats.org/drawingml/2006/main" r:embed="R44fc69a564594344"/>
+          <a:blip xmlns:r="http://schemas.openxmlformats.org/officeDocument/2006/relationships" xmlns:a="http://schemas.openxmlformats.org/drawingml/2006/main" r:embed="Rae41c3e7eba240a8"/>
           <a:srcRect xmlns:a="http://schemas.openxmlformats.org/drawingml/2006/main" l="0" t="0" r="0" b="0"/>
           <a:stretch xmlns:a="http://schemas.openxmlformats.org/drawingml/2006/main"/>
         </p:blipFill>
@@ -12152,7 +12420,7 @@
           <p:cNvPr id="5" name="">
             <a:extLst xmlns:a="http://schemas.openxmlformats.org/drawingml/2006/main">
               <a:ext uri="{FF2B5EF4-FFF2-40B4-BE49-F238E27FC236}">
-                <a16:creationId xmlns:a16="http://schemas.microsoft.com/office/drawing/2014/main" id="{727380D7-E8DD-4B1B-8144-A9A9BA7F556E}"/>
+                <a16:creationId xmlns:a16="http://schemas.microsoft.com/office/drawing/2014/main" id="{07295D30-3362-4365-AE3C-791E7DA16CA3}"/>
               </a:ext>
             </a:extLst>
           </p:cNvPr>
@@ -12162,7 +12430,7 @@
           <p:nvPr/>
         </p:nvPicPr>
         <p:blipFill>
-          <a:blip xmlns:r="http://schemas.openxmlformats.org/officeDocument/2006/relationships" xmlns:a="http://schemas.openxmlformats.org/drawingml/2006/main" r:embed="R8328aabeb9c94118"/>
+          <a:blip xmlns:r="http://schemas.openxmlformats.org/officeDocument/2006/relationships" xmlns:a="http://schemas.openxmlformats.org/drawingml/2006/main" r:embed="Rc125c774e0004b8e"/>
           <a:stretch xmlns:a="http://schemas.openxmlformats.org/drawingml/2006/main"/>
         </p:blipFill>
         <p:spPr>
@@ -12180,7 +12448,7 @@
           <p:cNvPr id="6" name="">
             <a:extLst xmlns:a="http://schemas.openxmlformats.org/drawingml/2006/main">
               <a:ext uri="{FF2B5EF4-FFF2-40B4-BE49-F238E27FC236}">
-                <a16:creationId xmlns:a16="http://schemas.microsoft.com/office/drawing/2014/main" id="{D9A10317-C620-4E9D-AACA-95168BE3945F}"/>
+                <a16:creationId xmlns:a16="http://schemas.microsoft.com/office/drawing/2014/main" id="{E9C95E9C-852B-4C54-9E7A-C114809C0EB4}"/>
               </a:ext>
             </a:extLst>
           </p:cNvPr>
@@ -12190,7 +12458,7 @@
           <p:nvPr/>
         </p:nvPicPr>
         <p:blipFill>
-          <a:blip xmlns:r="http://schemas.openxmlformats.org/officeDocument/2006/relationships" xmlns:a="http://schemas.openxmlformats.org/drawingml/2006/main" r:embed="R499403cce8c24c54"/>
+          <a:blip xmlns:r="http://schemas.openxmlformats.org/officeDocument/2006/relationships" xmlns:a="http://schemas.openxmlformats.org/drawingml/2006/main" r:embed="R18762b3c4ac547e1"/>
           <a:stretch xmlns:a="http://schemas.openxmlformats.org/drawingml/2006/main"/>
         </p:blipFill>
         <p:spPr>
@@ -12627,7 +12895,7 @@
           <p:cNvPr id="9" name="">
             <a:extLst xmlns:a="http://schemas.openxmlformats.org/drawingml/2006/main">
               <a:ext uri="{FF2B5EF4-FFF2-40B4-BE49-F238E27FC236}">
-                <a16:creationId xmlns:a16="http://schemas.microsoft.com/office/drawing/2014/main" id="{0CFAF001-7B72-4C69-9E5B-2FD4EBEC9F4D}"/>
+                <a16:creationId xmlns:a16="http://schemas.microsoft.com/office/drawing/2014/main" id="{D2351B23-7FFF-46DE-9C14-A1AA59D9E910}"/>
               </a:ext>
             </a:extLst>
           </p:cNvPr>
@@ -12637,7 +12905,7 @@
           <p:nvPr/>
         </p:nvPicPr>
         <p:blipFill>
-          <a:blip xmlns:r="http://schemas.openxmlformats.org/officeDocument/2006/relationships" xmlns:a="http://schemas.openxmlformats.org/drawingml/2006/main" r:embed="R14fd7d2b794b4d98"/>
+          <a:blip xmlns:r="http://schemas.openxmlformats.org/officeDocument/2006/relationships" xmlns:a="http://schemas.openxmlformats.org/drawingml/2006/main" r:embed="R17bb8c5f1f4a441a"/>
           <a:srcRect xmlns:a="http://schemas.openxmlformats.org/drawingml/2006/main" l="0" t="0" r="0" b="0"/>
           <a:stretch xmlns:a="http://schemas.openxmlformats.org/drawingml/2006/main"/>
         </p:blipFill>
@@ -12878,7 +13146,29 @@
                 <a:ea typeface="Helvetica Neue"/>
                 <a:cs typeface="Helvetica Neue"/>
               </a:rPr>
-              <a:t>Check gaps, adapt the outreach draft, then copy or export.</a:t>
+              <a:t>Check gaps, adapt the </a:t>
+            </a:r>
+            <a:r>
+              <a:rPr sz="2025" b="0">
+                <a:solidFill>
+                  <a:srgbClr val="123363"/>
+                </a:solidFill>
+                <a:latin typeface="Helvetica Neue"/>
+                <a:ea typeface="Helvetica Neue"/>
+                <a:cs typeface="Helvetica Neue"/>
+              </a:rPr>
+              <a:t>outreach message</a:t>
+            </a:r>
+            <a:r>
+              <a:rPr sz="2025" b="0">
+                <a:solidFill>
+                  <a:srgbClr val="123363"/>
+                </a:solidFill>
+                <a:latin typeface="Helvetica Neue"/>
+                <a:ea typeface="Helvetica Neue"/>
+                <a:cs typeface="Helvetica Neue"/>
+              </a:rPr>
+              <a:t>, then copy or export.</a:t>
             </a:r>
           </a:p>
         </p:txBody>
@@ -13013,6 +13303,7 @@
               </a:defRPr>
             </a:defPPr>
             <a:lvl1pPr>
+              <a:buNone/>
               <a:defRPr sz="2175" b="1">
                 <a:solidFill>
                   <a:srgbClr val="173B75"/>
@@ -13023,6 +13314,7 @@
               </a:defRPr>
             </a:lvl1pPr>
             <a:lvl2pPr>
+              <a:buNone/>
               <a:defRPr sz="2175" b="1">
                 <a:solidFill>
                   <a:srgbClr val="173B75"/>
@@ -13033,6 +13325,7 @@
               </a:defRPr>
             </a:lvl2pPr>
             <a:lvl3pPr>
+              <a:buNone/>
               <a:defRPr sz="2175" b="1">
                 <a:solidFill>
                   <a:srgbClr val="173B75"/>
@@ -13043,6 +13336,7 @@
               </a:defRPr>
             </a:lvl3pPr>
             <a:lvl4pPr>
+              <a:buNone/>
               <a:defRPr sz="2175" b="1">
                 <a:solidFill>
                   <a:srgbClr val="173B75"/>
@@ -13053,6 +13347,7 @@
               </a:defRPr>
             </a:lvl4pPr>
             <a:lvl5pPr>
+              <a:buNone/>
               <a:defRPr sz="2175" b="1">
                 <a:solidFill>
                   <a:srgbClr val="173B75"/>
@@ -13063,6 +13358,7 @@
               </a:defRPr>
             </a:lvl5pPr>
             <a:lvl6pPr>
+              <a:buNone/>
               <a:defRPr sz="2175" b="1">
                 <a:solidFill>
                   <a:srgbClr val="173B75"/>
@@ -13073,6 +13369,7 @@
               </a:defRPr>
             </a:lvl6pPr>
             <a:lvl7pPr>
+              <a:buNone/>
               <a:defRPr sz="2175" b="1">
                 <a:solidFill>
                   <a:srgbClr val="173B75"/>
@@ -13083,6 +13380,7 @@
               </a:defRPr>
             </a:lvl7pPr>
             <a:lvl8pPr>
+              <a:buNone/>
               <a:defRPr sz="2175" b="1">
                 <a:solidFill>
                   <a:srgbClr val="173B75"/>
@@ -13093,6 +13391,7 @@
               </a:defRPr>
             </a:lvl8pPr>
             <a:lvl9pPr>
+              <a:buNone/>
               <a:defRPr sz="2175" b="1">
                 <a:solidFill>
                   <a:srgbClr val="173B75"/>
@@ -13105,6 +13404,7 @@
           </a:lstStyle>
           <a:p xmlns:a="http://schemas.openxmlformats.org/drawingml/2006/main">
             <a:pPr>
+              <a:buNone/>
               <a:defRPr sz="2175" b="1">
                 <a:solidFill>
                   <a:srgbClr val="173B75"/>
@@ -13133,7 +13433,7 @@
           <p:cNvPr id="2" name="">
             <a:extLst xmlns:a="http://schemas.openxmlformats.org/drawingml/2006/main">
               <a:ext uri="{FF2B5EF4-FFF2-40B4-BE49-F238E27FC236}">
-                <a16:creationId xmlns:a16="http://schemas.microsoft.com/office/drawing/2014/main" id="{45E24609-DAC0-4C8E-82E1-86EA1C71CB14}"/>
+                <a16:creationId xmlns:a16="http://schemas.microsoft.com/office/drawing/2014/main" id="{D7F31CA2-0A6C-4362-A986-9F2655342BB5}"/>
               </a:ext>
             </a:extLst>
           </p:cNvPr>
@@ -13143,10 +13443,10 @@
           <p:nvPr/>
         </p:nvPicPr>
         <p:blipFill>
-          <a:blip xmlns:r="http://schemas.openxmlformats.org/officeDocument/2006/relationships" xmlns:a="http://schemas.openxmlformats.org/drawingml/2006/main" r:embed="R70a65fa51c184523">
+          <a:blip xmlns:r="http://schemas.openxmlformats.org/officeDocument/2006/relationships" xmlns:a="http://schemas.openxmlformats.org/drawingml/2006/main" r:embed="R617d0656bdfc4cec">
             <a:extLst>
               <a:ext uri="{96DAC541-7B7A-43D3-8B79-37D633B846F1}">
-                <asvg:svgBlip xmlns:asvg="http://schemas.microsoft.com/office/drawing/2016/SVG/main" r:embed="Rb16025ae2c8346d1"/>
+                <asvg:svgBlip xmlns:asvg="http://schemas.microsoft.com/office/drawing/2016/SVG/main" r:embed="R6d08e3cd458d4f40"/>
               </a:ext>
             </a:extLst>
           </a:blip>
@@ -13205,6 +13505,7 @@
               </a:defRPr>
             </a:defPPr>
             <a:lvl1pPr>
+              <a:buNone/>
               <a:defRPr sz="2850" b="1">
                 <a:solidFill>
                   <a:srgbClr val="173B75"/>
@@ -13215,6 +13516,7 @@
               </a:defRPr>
             </a:lvl1pPr>
             <a:lvl2pPr>
+              <a:buNone/>
               <a:defRPr sz="2850" b="1">
                 <a:solidFill>
                   <a:srgbClr val="173B75"/>
@@ -13225,6 +13527,7 @@
               </a:defRPr>
             </a:lvl2pPr>
             <a:lvl3pPr>
+              <a:buNone/>
               <a:defRPr sz="2850" b="1">
                 <a:solidFill>
                   <a:srgbClr val="173B75"/>
@@ -13235,6 +13538,7 @@
               </a:defRPr>
             </a:lvl3pPr>
             <a:lvl4pPr>
+              <a:buNone/>
               <a:defRPr sz="2850" b="1">
                 <a:solidFill>
                   <a:srgbClr val="173B75"/>
@@ -13245,6 +13549,7 @@
               </a:defRPr>
             </a:lvl4pPr>
             <a:lvl5pPr>
+              <a:buNone/>
               <a:defRPr sz="2850" b="1">
                 <a:solidFill>
                   <a:srgbClr val="173B75"/>
@@ -13255,6 +13560,7 @@
               </a:defRPr>
             </a:lvl5pPr>
             <a:lvl6pPr>
+              <a:buNone/>
               <a:defRPr sz="2850" b="1">
                 <a:solidFill>
                   <a:srgbClr val="173B75"/>
@@ -13265,6 +13571,7 @@
               </a:defRPr>
             </a:lvl6pPr>
             <a:lvl7pPr>
+              <a:buNone/>
               <a:defRPr sz="2850" b="1">
                 <a:solidFill>
                   <a:srgbClr val="173B75"/>
@@ -13275,6 +13582,7 @@
               </a:defRPr>
             </a:lvl7pPr>
             <a:lvl8pPr>
+              <a:buNone/>
               <a:defRPr sz="2850" b="1">
                 <a:solidFill>
                   <a:srgbClr val="173B75"/>
@@ -13285,6 +13593,7 @@
               </a:defRPr>
             </a:lvl8pPr>
             <a:lvl9pPr>
+              <a:buNone/>
               <a:defRPr sz="2850" b="1">
                 <a:solidFill>
                   <a:srgbClr val="173B75"/>
@@ -13297,6 +13606,7 @@
           </a:lstStyle>
           <a:p xmlns:a="http://schemas.openxmlformats.org/drawingml/2006/main">
             <a:pPr>
+              <a:buNone/>
               <a:defRPr sz="2850" b="1">
                 <a:solidFill>
                   <a:srgbClr val="173B75"/>
@@ -13363,6 +13673,7 @@
               </a:defRPr>
             </a:defPPr>
             <a:lvl1pPr>
+              <a:buNone/>
               <a:defRPr sz="1575" b="0">
                 <a:solidFill>
                   <a:srgbClr val="607DA3"/>
@@ -13373,6 +13684,7 @@
               </a:defRPr>
             </a:lvl1pPr>
             <a:lvl2pPr>
+              <a:buNone/>
               <a:defRPr sz="1575" b="0">
                 <a:solidFill>
                   <a:srgbClr val="607DA3"/>
@@ -13383,6 +13695,7 @@
               </a:defRPr>
             </a:lvl2pPr>
             <a:lvl3pPr>
+              <a:buNone/>
               <a:defRPr sz="1575" b="0">
                 <a:solidFill>
                   <a:srgbClr val="607DA3"/>
@@ -13393,6 +13706,7 @@
               </a:defRPr>
             </a:lvl3pPr>
             <a:lvl4pPr>
+              <a:buNone/>
               <a:defRPr sz="1575" b="0">
                 <a:solidFill>
                   <a:srgbClr val="607DA3"/>
@@ -13403,6 +13717,7 @@
               </a:defRPr>
             </a:lvl4pPr>
             <a:lvl5pPr>
+              <a:buNone/>
               <a:defRPr sz="1575" b="0">
                 <a:solidFill>
                   <a:srgbClr val="607DA3"/>
@@ -13413,6 +13728,7 @@
               </a:defRPr>
             </a:lvl5pPr>
             <a:lvl6pPr>
+              <a:buNone/>
               <a:defRPr sz="1575" b="0">
                 <a:solidFill>
                   <a:srgbClr val="607DA3"/>
@@ -13423,6 +13739,7 @@
               </a:defRPr>
             </a:lvl6pPr>
             <a:lvl7pPr>
+              <a:buNone/>
               <a:defRPr sz="1575" b="0">
                 <a:solidFill>
                   <a:srgbClr val="607DA3"/>
@@ -13433,6 +13750,7 @@
               </a:defRPr>
             </a:lvl7pPr>
             <a:lvl8pPr>
+              <a:buNone/>
               <a:defRPr sz="1575" b="0">
                 <a:solidFill>
                   <a:srgbClr val="607DA3"/>
@@ -13443,6 +13761,7 @@
               </a:defRPr>
             </a:lvl8pPr>
             <a:lvl9pPr>
+              <a:buNone/>
               <a:defRPr sz="1575" b="0">
                 <a:solidFill>
                   <a:srgbClr val="607DA3"/>
@@ -13455,6 +13774,7 @@
           </a:lstStyle>
           <a:p xmlns:a="http://schemas.openxmlformats.org/drawingml/2006/main">
             <a:pPr>
+              <a:buNone/>
               <a:defRPr sz="1575" b="0">
                 <a:solidFill>
                   <a:srgbClr val="607DA3"/>
@@ -13483,7 +13803,7 @@
           <p:cNvPr id="5" name="Blue process arrow">
             <a:extLst xmlns:a="http://schemas.openxmlformats.org/drawingml/2006/main">
               <a:ext uri="{FF2B5EF4-FFF2-40B4-BE49-F238E27FC236}">
-                <a16:creationId xmlns:a16="http://schemas.microsoft.com/office/drawing/2014/main" id="{14E90E5F-728E-40E6-ACA5-69AEFD38B0C6}"/>
+                <a16:creationId xmlns:a16="http://schemas.microsoft.com/office/drawing/2014/main" id="{86DA8142-C6DC-4CE4-910E-50C9FF8B25A6}"/>
               </a:ext>
             </a:extLst>
           </p:cNvPr>
@@ -13511,7 +13831,7 @@
           <p:cNvPr id="6" name="Blue process arrow">
             <a:extLst xmlns:a="http://schemas.openxmlformats.org/drawingml/2006/main">
               <a:ext uri="{FF2B5EF4-FFF2-40B4-BE49-F238E27FC236}">
-                <a16:creationId xmlns:a16="http://schemas.microsoft.com/office/drawing/2014/main" id="{E6558594-F76A-4375-A4CC-E8F72EAC36CD}"/>
+                <a16:creationId xmlns:a16="http://schemas.microsoft.com/office/drawing/2014/main" id="{58A9FD46-2E07-4E2A-AF42-57B9893FA05D}"/>
               </a:ext>
             </a:extLst>
           </p:cNvPr>
@@ -13539,7 +13859,7 @@
           <p:cNvPr id="7" name="Blue process arrow">
             <a:extLst xmlns:a="http://schemas.openxmlformats.org/drawingml/2006/main">
               <a:ext uri="{FF2B5EF4-FFF2-40B4-BE49-F238E27FC236}">
-                <a16:creationId xmlns:a16="http://schemas.microsoft.com/office/drawing/2014/main" id="{124CE001-EDBA-4A77-825B-9E1653D7520B}"/>
+                <a16:creationId xmlns:a16="http://schemas.microsoft.com/office/drawing/2014/main" id="{0FF4CAD3-7E31-4A0C-8408-1CB027E5BF4D}"/>
               </a:ext>
             </a:extLst>
           </p:cNvPr>
@@ -13567,7 +13887,7 @@
           <p:cNvPr id="8" name="Blue process arrow">
             <a:extLst xmlns:a="http://schemas.openxmlformats.org/drawingml/2006/main">
               <a:ext uri="{FF2B5EF4-FFF2-40B4-BE49-F238E27FC236}">
-                <a16:creationId xmlns:a16="http://schemas.microsoft.com/office/drawing/2014/main" id="{C5BA7315-4B75-4234-8F70-A02FB99E1472}"/>
+                <a16:creationId xmlns:a16="http://schemas.microsoft.com/office/drawing/2014/main" id="{682E816D-AA33-48AC-BF09-5C02A7D6233A}"/>
               </a:ext>
             </a:extLst>
           </p:cNvPr>
@@ -13595,7 +13915,7 @@
           <p:cNvPr id="9" name="Blue process arrow">
             <a:extLst xmlns:a="http://schemas.openxmlformats.org/drawingml/2006/main">
               <a:ext uri="{FF2B5EF4-FFF2-40B4-BE49-F238E27FC236}">
-                <a16:creationId xmlns:a16="http://schemas.microsoft.com/office/drawing/2014/main" id="{AF3D3FCD-CF92-40A1-A90F-3DE6B7C70A72}"/>
+                <a16:creationId xmlns:a16="http://schemas.microsoft.com/office/drawing/2014/main" id="{F38A085E-BD02-4434-B1F1-C2528E1A73A4}"/>
               </a:ext>
             </a:extLst>
           </p:cNvPr>
@@ -13622,7 +13942,7 @@
           <p:cNvPr id="10" name="Blue process arrow">
             <a:extLst xmlns:a="http://schemas.openxmlformats.org/drawingml/2006/main">
               <a:ext uri="{FF2B5EF4-FFF2-40B4-BE49-F238E27FC236}">
-                <a16:creationId xmlns:a16="http://schemas.microsoft.com/office/drawing/2014/main" id="{E353304F-B522-4AFD-83FF-9350C4082529}"/>
+                <a16:creationId xmlns:a16="http://schemas.microsoft.com/office/drawing/2014/main" id="{A00A446A-C79A-4842-B206-32965B9C8436}"/>
               </a:ext>
             </a:extLst>
           </p:cNvPr>
@@ -13649,7 +13969,7 @@
           <p:cNvPr id="11" name="Blue process arrow">
             <a:extLst xmlns:a="http://schemas.openxmlformats.org/drawingml/2006/main">
               <a:ext uri="{FF2B5EF4-FFF2-40B4-BE49-F238E27FC236}">
-                <a16:creationId xmlns:a16="http://schemas.microsoft.com/office/drawing/2014/main" id="{E3E20CE5-7F22-4A24-98DF-6758481CA1DE}"/>
+                <a16:creationId xmlns:a16="http://schemas.microsoft.com/office/drawing/2014/main" id="{1D7958D7-346E-4B1F-B446-72D31F845F24}"/>
               </a:ext>
             </a:extLst>
           </p:cNvPr>
@@ -13677,7 +13997,7 @@
           <p:cNvPr id="12" name="Blue process arrow">
             <a:extLst xmlns:a="http://schemas.openxmlformats.org/drawingml/2006/main">
               <a:ext uri="{FF2B5EF4-FFF2-40B4-BE49-F238E27FC236}">
-                <a16:creationId xmlns:a16="http://schemas.microsoft.com/office/drawing/2014/main" id="{64375664-D30E-45F1-85B6-A679716E4A00}"/>
+                <a16:creationId xmlns:a16="http://schemas.microsoft.com/office/drawing/2014/main" id="{DCC4BFCF-FB46-4F11-982A-E7ADB766A49F}"/>
               </a:ext>
             </a:extLst>
           </p:cNvPr>
@@ -13704,7 +14024,7 @@
           <p:cNvPr id="13" name="Blue process arrow">
             <a:extLst xmlns:a="http://schemas.openxmlformats.org/drawingml/2006/main">
               <a:ext uri="{FF2B5EF4-FFF2-40B4-BE49-F238E27FC236}">
-                <a16:creationId xmlns:a16="http://schemas.microsoft.com/office/drawing/2014/main" id="{5C4769B4-DA5A-4DA2-883D-73E81DE14B2A}"/>
+                <a16:creationId xmlns:a16="http://schemas.microsoft.com/office/drawing/2014/main" id="{F0DA3ADE-9322-469C-8CE7-0EE09F7F9991}"/>
               </a:ext>
             </a:extLst>
           </p:cNvPr>
@@ -13731,7 +14051,7 @@
           <p:cNvPr id="14" name="Blue process arrow">
             <a:extLst xmlns:a="http://schemas.openxmlformats.org/drawingml/2006/main">
               <a:ext uri="{FF2B5EF4-FFF2-40B4-BE49-F238E27FC236}">
-                <a16:creationId xmlns:a16="http://schemas.microsoft.com/office/drawing/2014/main" id="{1129A719-F6A0-4216-8D1A-16C27CD8A836}"/>
+                <a16:creationId xmlns:a16="http://schemas.microsoft.com/office/drawing/2014/main" id="{42D45A54-CE3C-4A0D-9F9E-225C268E816A}"/>
               </a:ext>
             </a:extLst>
           </p:cNvPr>
@@ -13758,7 +14078,7 @@
           <p:cNvPr id="15" name="Blue process arrow">
             <a:extLst xmlns:a="http://schemas.openxmlformats.org/drawingml/2006/main">
               <a:ext uri="{FF2B5EF4-FFF2-40B4-BE49-F238E27FC236}">
-                <a16:creationId xmlns:a16="http://schemas.microsoft.com/office/drawing/2014/main" id="{F57EC5D2-B41D-4973-AE7C-0DAE27AF89DC}"/>
+                <a16:creationId xmlns:a16="http://schemas.microsoft.com/office/drawing/2014/main" id="{A1C7474D-2946-4F8C-AA20-007025737283}"/>
               </a:ext>
             </a:extLst>
           </p:cNvPr>
@@ -13786,7 +14106,7 @@
           <p:cNvPr id="16" name="Blue process arrow">
             <a:extLst xmlns:a="http://schemas.openxmlformats.org/drawingml/2006/main">
               <a:ext uri="{FF2B5EF4-FFF2-40B4-BE49-F238E27FC236}">
-                <a16:creationId xmlns:a16="http://schemas.microsoft.com/office/drawing/2014/main" id="{17FA439D-D0A2-47FC-BBED-4A9FC0123CD8}"/>
+                <a16:creationId xmlns:a16="http://schemas.microsoft.com/office/drawing/2014/main" id="{366EC5CF-327F-4410-827A-75119787C8CE}"/>
               </a:ext>
             </a:extLst>
           </p:cNvPr>
@@ -13886,6 +14206,7 @@
               </a:defRPr>
             </a:defPPr>
             <a:lvl1pPr>
+              <a:buNone/>
               <a:defRPr sz="1575" b="1">
                 <a:solidFill>
                   <a:srgbClr val="1768C7"/>
@@ -13896,6 +14217,7 @@
               </a:defRPr>
             </a:lvl1pPr>
             <a:lvl2pPr>
+              <a:buNone/>
               <a:defRPr sz="1575" b="1">
                 <a:solidFill>
                   <a:srgbClr val="1768C7"/>
@@ -13906,6 +14228,7 @@
               </a:defRPr>
             </a:lvl2pPr>
             <a:lvl3pPr>
+              <a:buNone/>
               <a:defRPr sz="1575" b="1">
                 <a:solidFill>
                   <a:srgbClr val="1768C7"/>
@@ -13916,6 +14239,7 @@
               </a:defRPr>
             </a:lvl3pPr>
             <a:lvl4pPr>
+              <a:buNone/>
               <a:defRPr sz="1575" b="1">
                 <a:solidFill>
                   <a:srgbClr val="1768C7"/>
@@ -13926,6 +14250,7 @@
               </a:defRPr>
             </a:lvl4pPr>
             <a:lvl5pPr>
+              <a:buNone/>
               <a:defRPr sz="1575" b="1">
                 <a:solidFill>
                   <a:srgbClr val="1768C7"/>
@@ -13936,6 +14261,7 @@
               </a:defRPr>
             </a:lvl5pPr>
             <a:lvl6pPr>
+              <a:buNone/>
               <a:defRPr sz="1575" b="1">
                 <a:solidFill>
                   <a:srgbClr val="1768C7"/>
@@ -13946,6 +14272,7 @@
               </a:defRPr>
             </a:lvl6pPr>
             <a:lvl7pPr>
+              <a:buNone/>
               <a:defRPr sz="1575" b="1">
                 <a:solidFill>
                   <a:srgbClr val="1768C7"/>
@@ -13956,6 +14283,7 @@
               </a:defRPr>
             </a:lvl7pPr>
             <a:lvl8pPr>
+              <a:buNone/>
               <a:defRPr sz="1575" b="1">
                 <a:solidFill>
                   <a:srgbClr val="1768C7"/>
@@ -13966,6 +14294,7 @@
               </a:defRPr>
             </a:lvl8pPr>
             <a:lvl9pPr>
+              <a:buNone/>
               <a:defRPr sz="1575" b="1">
                 <a:solidFill>
                   <a:srgbClr val="1768C7"/>
@@ -13978,6 +14307,7 @@
           </a:lstStyle>
           <a:p xmlns:a="http://schemas.openxmlformats.org/drawingml/2006/main">
             <a:pPr>
+              <a:buNone/>
               <a:defRPr sz="1575" b="1">
                 <a:solidFill>
                   <a:srgbClr val="1768C7"/>
@@ -14044,6 +14374,7 @@
               </a:defRPr>
             </a:defPPr>
             <a:lvl1pPr>
+              <a:buNone/>
               <a:defRPr sz="1500" b="0">
                 <a:solidFill>
                   <a:srgbClr val="173B75"/>
@@ -14054,6 +14385,7 @@
               </a:defRPr>
             </a:lvl1pPr>
             <a:lvl2pPr>
+              <a:buNone/>
               <a:defRPr sz="1500" b="0">
                 <a:solidFill>
                   <a:srgbClr val="173B75"/>
@@ -14064,6 +14396,7 @@
               </a:defRPr>
             </a:lvl2pPr>
             <a:lvl3pPr>
+              <a:buNone/>
               <a:defRPr sz="1500" b="0">
                 <a:solidFill>
                   <a:srgbClr val="173B75"/>
@@ -14074,6 +14407,7 @@
               </a:defRPr>
             </a:lvl3pPr>
             <a:lvl4pPr>
+              <a:buNone/>
               <a:defRPr sz="1500" b="0">
                 <a:solidFill>
                   <a:srgbClr val="173B75"/>
@@ -14084,6 +14418,7 @@
               </a:defRPr>
             </a:lvl4pPr>
             <a:lvl5pPr>
+              <a:buNone/>
               <a:defRPr sz="1500" b="0">
                 <a:solidFill>
                   <a:srgbClr val="173B75"/>
@@ -14094,6 +14429,7 @@
               </a:defRPr>
             </a:lvl5pPr>
             <a:lvl6pPr>
+              <a:buNone/>
               <a:defRPr sz="1500" b="0">
                 <a:solidFill>
                   <a:srgbClr val="173B75"/>
@@ -14104,6 +14440,7 @@
               </a:defRPr>
             </a:lvl6pPr>
             <a:lvl7pPr>
+              <a:buNone/>
               <a:defRPr sz="1500" b="0">
                 <a:solidFill>
                   <a:srgbClr val="173B75"/>
@@ -14114,6 +14451,7 @@
               </a:defRPr>
             </a:lvl7pPr>
             <a:lvl8pPr>
+              <a:buNone/>
               <a:defRPr sz="1500" b="0">
                 <a:solidFill>
                   <a:srgbClr val="173B75"/>
@@ -14124,6 +14462,7 @@
               </a:defRPr>
             </a:lvl8pPr>
             <a:lvl9pPr>
+              <a:buNone/>
               <a:defRPr sz="1500" b="0">
                 <a:solidFill>
                   <a:srgbClr val="173B75"/>
@@ -14136,6 +14475,7 @@
           </a:lstStyle>
           <a:p xmlns:a="http://schemas.openxmlformats.org/drawingml/2006/main">
             <a:pPr>
+              <a:buNone/>
               <a:defRPr sz="1500" b="0">
                 <a:solidFill>
                   <a:srgbClr val="173B75"/>
@@ -14159,6 +14499,7 @@
           </a:p>
           <a:p xmlns:a="http://schemas.openxmlformats.org/drawingml/2006/main">
             <a:pPr>
+              <a:buNone/>
               <a:defRPr sz="1500" b="0">
                 <a:solidFill>
                   <a:srgbClr val="173B75"/>
@@ -14259,6 +14600,7 @@
               </a:defRPr>
             </a:defPPr>
             <a:lvl1pPr>
+              <a:buNone/>
               <a:defRPr sz="1575" b="1">
                 <a:solidFill>
                   <a:srgbClr val="1768C7"/>
@@ -14269,6 +14611,7 @@
               </a:defRPr>
             </a:lvl1pPr>
             <a:lvl2pPr>
+              <a:buNone/>
               <a:defRPr sz="1575" b="1">
                 <a:solidFill>
                   <a:srgbClr val="1768C7"/>
@@ -14279,6 +14622,7 @@
               </a:defRPr>
             </a:lvl2pPr>
             <a:lvl3pPr>
+              <a:buNone/>
               <a:defRPr sz="1575" b="1">
                 <a:solidFill>
                   <a:srgbClr val="1768C7"/>
@@ -14289,6 +14633,7 @@
               </a:defRPr>
             </a:lvl3pPr>
             <a:lvl4pPr>
+              <a:buNone/>
               <a:defRPr sz="1575" b="1">
                 <a:solidFill>
                   <a:srgbClr val="1768C7"/>
@@ -14299,6 +14644,7 @@
               </a:defRPr>
             </a:lvl4pPr>
             <a:lvl5pPr>
+              <a:buNone/>
               <a:defRPr sz="1575" b="1">
                 <a:solidFill>
                   <a:srgbClr val="1768C7"/>
@@ -14309,6 +14655,7 @@
               </a:defRPr>
             </a:lvl5pPr>
             <a:lvl6pPr>
+              <a:buNone/>
               <a:defRPr sz="1575" b="1">
                 <a:solidFill>
                   <a:srgbClr val="1768C7"/>
@@ -14319,6 +14666,7 @@
               </a:defRPr>
             </a:lvl6pPr>
             <a:lvl7pPr>
+              <a:buNone/>
               <a:defRPr sz="1575" b="1">
                 <a:solidFill>
                   <a:srgbClr val="1768C7"/>
@@ -14329,6 +14677,7 @@
               </a:defRPr>
             </a:lvl7pPr>
             <a:lvl8pPr>
+              <a:buNone/>
               <a:defRPr sz="1575" b="1">
                 <a:solidFill>
                   <a:srgbClr val="1768C7"/>
@@ -14339,6 +14688,7 @@
               </a:defRPr>
             </a:lvl8pPr>
             <a:lvl9pPr>
+              <a:buNone/>
               <a:defRPr sz="1575" b="1">
                 <a:solidFill>
                   <a:srgbClr val="1768C7"/>
@@ -14351,6 +14701,7 @@
           </a:lstStyle>
           <a:p xmlns:a="http://schemas.openxmlformats.org/drawingml/2006/main">
             <a:pPr>
+              <a:buNone/>
               <a:defRPr sz="1575" b="1">
                 <a:solidFill>
                   <a:srgbClr val="1768C7"/>
@@ -14417,6 +14768,7 @@
               </a:defRPr>
             </a:defPPr>
             <a:lvl1pPr>
+              <a:buNone/>
               <a:defRPr sz="1500" b="0">
                 <a:solidFill>
                   <a:srgbClr val="173B75"/>
@@ -14427,6 +14779,7 @@
               </a:defRPr>
             </a:lvl1pPr>
             <a:lvl2pPr>
+              <a:buNone/>
               <a:defRPr sz="1500" b="0">
                 <a:solidFill>
                   <a:srgbClr val="173B75"/>
@@ -14437,6 +14790,7 @@
               </a:defRPr>
             </a:lvl2pPr>
             <a:lvl3pPr>
+              <a:buNone/>
               <a:defRPr sz="1500" b="0">
                 <a:solidFill>
                   <a:srgbClr val="173B75"/>
@@ -14447,6 +14801,7 @@
               </a:defRPr>
             </a:lvl3pPr>
             <a:lvl4pPr>
+              <a:buNone/>
               <a:defRPr sz="1500" b="0">
                 <a:solidFill>
                   <a:srgbClr val="173B75"/>
@@ -14457,6 +14812,7 @@
               </a:defRPr>
             </a:lvl4pPr>
             <a:lvl5pPr>
+              <a:buNone/>
               <a:defRPr sz="1500" b="0">
                 <a:solidFill>
                   <a:srgbClr val="173B75"/>
@@ -14467,6 +14823,7 @@
               </a:defRPr>
             </a:lvl5pPr>
             <a:lvl6pPr>
+              <a:buNone/>
               <a:defRPr sz="1500" b="0">
                 <a:solidFill>
                   <a:srgbClr val="173B75"/>
@@ -14477,6 +14834,7 @@
               </a:defRPr>
             </a:lvl6pPr>
             <a:lvl7pPr>
+              <a:buNone/>
               <a:defRPr sz="1500" b="0">
                 <a:solidFill>
                   <a:srgbClr val="173B75"/>
@@ -14487,6 +14845,7 @@
               </a:defRPr>
             </a:lvl7pPr>
             <a:lvl8pPr>
+              <a:buNone/>
               <a:defRPr sz="1500" b="0">
                 <a:solidFill>
                   <a:srgbClr val="173B75"/>
@@ -14497,6 +14856,7 @@
               </a:defRPr>
             </a:lvl8pPr>
             <a:lvl9pPr>
+              <a:buNone/>
               <a:defRPr sz="1500" b="0">
                 <a:solidFill>
                   <a:srgbClr val="173B75"/>
@@ -14509,6 +14869,7 @@
           </a:lstStyle>
           <a:p xmlns:a="http://schemas.openxmlformats.org/drawingml/2006/main">
             <a:pPr>
+              <a:buNone/>
               <a:defRPr sz="1500" b="0">
                 <a:solidFill>
                   <a:srgbClr val="173B75"/>
@@ -14532,6 +14893,7 @@
           </a:p>
           <a:p xmlns:a="http://schemas.openxmlformats.org/drawingml/2006/main">
             <a:pPr>
+              <a:buNone/>
               <a:defRPr sz="1500" b="0">
                 <a:solidFill>
                   <a:srgbClr val="173B75"/>
@@ -14632,6 +14994,7 @@
               </a:defRPr>
             </a:defPPr>
             <a:lvl1pPr>
+              <a:buNone/>
               <a:defRPr sz="1575" b="1">
                 <a:solidFill>
                   <a:srgbClr val="1768C7"/>
@@ -14642,6 +15005,7 @@
               </a:defRPr>
             </a:lvl1pPr>
             <a:lvl2pPr>
+              <a:buNone/>
               <a:defRPr sz="1575" b="1">
                 <a:solidFill>
                   <a:srgbClr val="1768C7"/>
@@ -14652,6 +15016,7 @@
               </a:defRPr>
             </a:lvl2pPr>
             <a:lvl3pPr>
+              <a:buNone/>
               <a:defRPr sz="1575" b="1">
                 <a:solidFill>
                   <a:srgbClr val="1768C7"/>
@@ -14662,6 +15027,7 @@
               </a:defRPr>
             </a:lvl3pPr>
             <a:lvl4pPr>
+              <a:buNone/>
               <a:defRPr sz="1575" b="1">
                 <a:solidFill>
                   <a:srgbClr val="1768C7"/>
@@ -14672,6 +15038,7 @@
               </a:defRPr>
             </a:lvl4pPr>
             <a:lvl5pPr>
+              <a:buNone/>
               <a:defRPr sz="1575" b="1">
                 <a:solidFill>
                   <a:srgbClr val="1768C7"/>
@@ -14682,6 +15049,7 @@
               </a:defRPr>
             </a:lvl5pPr>
             <a:lvl6pPr>
+              <a:buNone/>
               <a:defRPr sz="1575" b="1">
                 <a:solidFill>
                   <a:srgbClr val="1768C7"/>
@@ -14692,6 +15060,7 @@
               </a:defRPr>
             </a:lvl6pPr>
             <a:lvl7pPr>
+              <a:buNone/>
               <a:defRPr sz="1575" b="1">
                 <a:solidFill>
                   <a:srgbClr val="1768C7"/>
@@ -14702,6 +15071,7 @@
               </a:defRPr>
             </a:lvl7pPr>
             <a:lvl8pPr>
+              <a:buNone/>
               <a:defRPr sz="1575" b="1">
                 <a:solidFill>
                   <a:srgbClr val="1768C7"/>
@@ -14712,6 +15082,7 @@
               </a:defRPr>
             </a:lvl8pPr>
             <a:lvl9pPr>
+              <a:buNone/>
               <a:defRPr sz="1575" b="1">
                 <a:solidFill>
                   <a:srgbClr val="1768C7"/>
@@ -14724,6 +15095,7 @@
           </a:lstStyle>
           <a:p xmlns:a="http://schemas.openxmlformats.org/drawingml/2006/main">
             <a:pPr>
+              <a:buNone/>
               <a:defRPr sz="1575" b="1">
                 <a:solidFill>
                   <a:srgbClr val="1768C7"/>
@@ -14790,6 +15162,7 @@
               </a:defRPr>
             </a:defPPr>
             <a:lvl1pPr>
+              <a:buNone/>
               <a:defRPr sz="1500" b="0">
                 <a:solidFill>
                   <a:srgbClr val="173B75"/>
@@ -14800,6 +15173,7 @@
               </a:defRPr>
             </a:lvl1pPr>
             <a:lvl2pPr>
+              <a:buNone/>
               <a:defRPr sz="1500" b="0">
                 <a:solidFill>
                   <a:srgbClr val="173B75"/>
@@ -14810,6 +15184,7 @@
               </a:defRPr>
             </a:lvl2pPr>
             <a:lvl3pPr>
+              <a:buNone/>
               <a:defRPr sz="1500" b="0">
                 <a:solidFill>
                   <a:srgbClr val="173B75"/>
@@ -14820,6 +15195,7 @@
               </a:defRPr>
             </a:lvl3pPr>
             <a:lvl4pPr>
+              <a:buNone/>
               <a:defRPr sz="1500" b="0">
                 <a:solidFill>
                   <a:srgbClr val="173B75"/>
@@ -14830,6 +15206,7 @@
               </a:defRPr>
             </a:lvl4pPr>
             <a:lvl5pPr>
+              <a:buNone/>
               <a:defRPr sz="1500" b="0">
                 <a:solidFill>
                   <a:srgbClr val="173B75"/>
@@ -14840,6 +15217,7 @@
               </a:defRPr>
             </a:lvl5pPr>
             <a:lvl6pPr>
+              <a:buNone/>
               <a:defRPr sz="1500" b="0">
                 <a:solidFill>
                   <a:srgbClr val="173B75"/>
@@ -14850,6 +15228,7 @@
               </a:defRPr>
             </a:lvl6pPr>
             <a:lvl7pPr>
+              <a:buNone/>
               <a:defRPr sz="1500" b="0">
                 <a:solidFill>
                   <a:srgbClr val="173B75"/>
@@ -14860,6 +15239,7 @@
               </a:defRPr>
             </a:lvl7pPr>
             <a:lvl8pPr>
+              <a:buNone/>
               <a:defRPr sz="1500" b="0">
                 <a:solidFill>
                   <a:srgbClr val="173B75"/>
@@ -14870,6 +15250,7 @@
               </a:defRPr>
             </a:lvl8pPr>
             <a:lvl9pPr>
+              <a:buNone/>
               <a:defRPr sz="1500" b="0">
                 <a:solidFill>
                   <a:srgbClr val="173B75"/>
@@ -14882,6 +15263,7 @@
           </a:lstStyle>
           <a:p xmlns:a="http://schemas.openxmlformats.org/drawingml/2006/main">
             <a:pPr>
+              <a:buNone/>
               <a:defRPr sz="1500" b="0">
                 <a:solidFill>
                   <a:srgbClr val="173B75"/>
@@ -14905,6 +15287,7 @@
           </a:p>
           <a:p xmlns:a="http://schemas.openxmlformats.org/drawingml/2006/main">
             <a:pPr>
+              <a:buNone/>
               <a:defRPr sz="1500" b="0">
                 <a:solidFill>
                   <a:srgbClr val="173B75"/>
@@ -15005,6 +15388,7 @@
               </a:defRPr>
             </a:defPPr>
             <a:lvl1pPr>
+              <a:buNone/>
               <a:defRPr sz="1575" b="1">
                 <a:solidFill>
                   <a:srgbClr val="1768C7"/>
@@ -15015,6 +15399,7 @@
               </a:defRPr>
             </a:lvl1pPr>
             <a:lvl2pPr>
+              <a:buNone/>
               <a:defRPr sz="1575" b="1">
                 <a:solidFill>
                   <a:srgbClr val="1768C7"/>
@@ -15025,6 +15410,7 @@
               </a:defRPr>
             </a:lvl2pPr>
             <a:lvl3pPr>
+              <a:buNone/>
               <a:defRPr sz="1575" b="1">
                 <a:solidFill>
                   <a:srgbClr val="1768C7"/>
@@ -15035,6 +15421,7 @@
               </a:defRPr>
             </a:lvl3pPr>
             <a:lvl4pPr>
+              <a:buNone/>
               <a:defRPr sz="1575" b="1">
                 <a:solidFill>
                   <a:srgbClr val="1768C7"/>
@@ -15045,6 +15432,7 @@
               </a:defRPr>
             </a:lvl4pPr>
             <a:lvl5pPr>
+              <a:buNone/>
               <a:defRPr sz="1575" b="1">
                 <a:solidFill>
                   <a:srgbClr val="1768C7"/>
@@ -15055,6 +15443,7 @@
               </a:defRPr>
             </a:lvl5pPr>
             <a:lvl6pPr>
+              <a:buNone/>
               <a:defRPr sz="1575" b="1">
                 <a:solidFill>
                   <a:srgbClr val="1768C7"/>
@@ -15065,6 +15454,7 @@
               </a:defRPr>
             </a:lvl6pPr>
             <a:lvl7pPr>
+              <a:buNone/>
               <a:defRPr sz="1575" b="1">
                 <a:solidFill>
                   <a:srgbClr val="1768C7"/>
@@ -15075,6 +15465,7 @@
               </a:defRPr>
             </a:lvl7pPr>
             <a:lvl8pPr>
+              <a:buNone/>
               <a:defRPr sz="1575" b="1">
                 <a:solidFill>
                   <a:srgbClr val="1768C7"/>
@@ -15085,6 +15476,7 @@
               </a:defRPr>
             </a:lvl8pPr>
             <a:lvl9pPr>
+              <a:buNone/>
               <a:defRPr sz="1575" b="1">
                 <a:solidFill>
                   <a:srgbClr val="1768C7"/>
@@ -15097,6 +15489,7 @@
           </a:lstStyle>
           <a:p xmlns:a="http://schemas.openxmlformats.org/drawingml/2006/main">
             <a:pPr>
+              <a:buNone/>
               <a:defRPr sz="1575" b="1">
                 <a:solidFill>
                   <a:srgbClr val="1768C7"/>
@@ -15163,6 +15556,7 @@
               </a:defRPr>
             </a:defPPr>
             <a:lvl1pPr>
+              <a:buNone/>
               <a:defRPr sz="1500" b="0">
                 <a:solidFill>
                   <a:srgbClr val="173B75"/>
@@ -15173,6 +15567,7 @@
               </a:defRPr>
             </a:lvl1pPr>
             <a:lvl2pPr>
+              <a:buNone/>
               <a:defRPr sz="1500" b="0">
                 <a:solidFill>
                   <a:srgbClr val="173B75"/>
@@ -15183,6 +15578,7 @@
               </a:defRPr>
             </a:lvl2pPr>
             <a:lvl3pPr>
+              <a:buNone/>
               <a:defRPr sz="1500" b="0">
                 <a:solidFill>
                   <a:srgbClr val="173B75"/>
@@ -15193,6 +15589,7 @@
               </a:defRPr>
             </a:lvl3pPr>
             <a:lvl4pPr>
+              <a:buNone/>
               <a:defRPr sz="1500" b="0">
                 <a:solidFill>
                   <a:srgbClr val="173B75"/>
@@ -15203,6 +15600,7 @@
               </a:defRPr>
             </a:lvl4pPr>
             <a:lvl5pPr>
+              <a:buNone/>
               <a:defRPr sz="1500" b="0">
                 <a:solidFill>
                   <a:srgbClr val="173B75"/>
@@ -15213,6 +15611,7 @@
               </a:defRPr>
             </a:lvl5pPr>
             <a:lvl6pPr>
+              <a:buNone/>
               <a:defRPr sz="1500" b="0">
                 <a:solidFill>
                   <a:srgbClr val="173B75"/>
@@ -15223,6 +15622,7 @@
               </a:defRPr>
             </a:lvl6pPr>
             <a:lvl7pPr>
+              <a:buNone/>
               <a:defRPr sz="1500" b="0">
                 <a:solidFill>
                   <a:srgbClr val="173B75"/>
@@ -15233,6 +15633,7 @@
               </a:defRPr>
             </a:lvl7pPr>
             <a:lvl8pPr>
+              <a:buNone/>
               <a:defRPr sz="1500" b="0">
                 <a:solidFill>
                   <a:srgbClr val="173B75"/>
@@ -15243,6 +15644,7 @@
               </a:defRPr>
             </a:lvl8pPr>
             <a:lvl9pPr>
+              <a:buNone/>
               <a:defRPr sz="1500" b="0">
                 <a:solidFill>
                   <a:srgbClr val="173B75"/>
@@ -15255,6 +15657,7 @@
           </a:lstStyle>
           <a:p xmlns:a="http://schemas.openxmlformats.org/drawingml/2006/main">
             <a:pPr>
+              <a:buNone/>
               <a:defRPr sz="1500" b="0">
                 <a:solidFill>
                   <a:srgbClr val="173B75"/>
@@ -15278,6 +15681,7 @@
           </a:p>
           <a:p xmlns:a="http://schemas.openxmlformats.org/drawingml/2006/main">
             <a:pPr>
+              <a:buNone/>
               <a:defRPr sz="1500" b="0">
                 <a:solidFill>
                   <a:srgbClr val="173B75"/>
@@ -15378,6 +15782,7 @@
               </a:defRPr>
             </a:defPPr>
             <a:lvl1pPr>
+              <a:buNone/>
               <a:defRPr sz="1575" b="1">
                 <a:solidFill>
                   <a:srgbClr val="1768C7"/>
@@ -15388,6 +15793,7 @@
               </a:defRPr>
             </a:lvl1pPr>
             <a:lvl2pPr>
+              <a:buNone/>
               <a:defRPr sz="1575" b="1">
                 <a:solidFill>
                   <a:srgbClr val="1768C7"/>
@@ -15398,6 +15804,7 @@
               </a:defRPr>
             </a:lvl2pPr>
             <a:lvl3pPr>
+              <a:buNone/>
               <a:defRPr sz="1575" b="1">
                 <a:solidFill>
                   <a:srgbClr val="1768C7"/>
@@ -15408,6 +15815,7 @@
               </a:defRPr>
             </a:lvl3pPr>
             <a:lvl4pPr>
+              <a:buNone/>
               <a:defRPr sz="1575" b="1">
                 <a:solidFill>
                   <a:srgbClr val="1768C7"/>
@@ -15418,6 +15826,7 @@
               </a:defRPr>
             </a:lvl4pPr>
             <a:lvl5pPr>
+              <a:buNone/>
               <a:defRPr sz="1575" b="1">
                 <a:solidFill>
                   <a:srgbClr val="1768C7"/>
@@ -15428,6 +15837,7 @@
               </a:defRPr>
             </a:lvl5pPr>
             <a:lvl6pPr>
+              <a:buNone/>
               <a:defRPr sz="1575" b="1">
                 <a:solidFill>
                   <a:srgbClr val="1768C7"/>
@@ -15438,6 +15848,7 @@
               </a:defRPr>
             </a:lvl6pPr>
             <a:lvl7pPr>
+              <a:buNone/>
               <a:defRPr sz="1575" b="1">
                 <a:solidFill>
                   <a:srgbClr val="1768C7"/>
@@ -15448,6 +15859,7 @@
               </a:defRPr>
             </a:lvl7pPr>
             <a:lvl8pPr>
+              <a:buNone/>
               <a:defRPr sz="1575" b="1">
                 <a:solidFill>
                   <a:srgbClr val="1768C7"/>
@@ -15458,6 +15870,7 @@
               </a:defRPr>
             </a:lvl8pPr>
             <a:lvl9pPr>
+              <a:buNone/>
               <a:defRPr sz="1575" b="1">
                 <a:solidFill>
                   <a:srgbClr val="1768C7"/>
@@ -15470,6 +15883,7 @@
           </a:lstStyle>
           <a:p xmlns:a="http://schemas.openxmlformats.org/drawingml/2006/main">
             <a:pPr>
+              <a:buNone/>
               <a:defRPr sz="1575" b="1">
                 <a:solidFill>
                   <a:srgbClr val="1768C7"/>
@@ -15536,6 +15950,7 @@
               </a:defRPr>
             </a:defPPr>
             <a:lvl1pPr>
+              <a:buNone/>
               <a:defRPr sz="1500" b="0">
                 <a:solidFill>
                   <a:srgbClr val="173B75"/>
@@ -15546,6 +15961,7 @@
               </a:defRPr>
             </a:lvl1pPr>
             <a:lvl2pPr>
+              <a:buNone/>
               <a:defRPr sz="1500" b="0">
                 <a:solidFill>
                   <a:srgbClr val="173B75"/>
@@ -15556,6 +15972,7 @@
               </a:defRPr>
             </a:lvl2pPr>
             <a:lvl3pPr>
+              <a:buNone/>
               <a:defRPr sz="1500" b="0">
                 <a:solidFill>
                   <a:srgbClr val="173B75"/>
@@ -15566,6 +15983,7 @@
               </a:defRPr>
             </a:lvl3pPr>
             <a:lvl4pPr>
+              <a:buNone/>
               <a:defRPr sz="1500" b="0">
                 <a:solidFill>
                   <a:srgbClr val="173B75"/>
@@ -15576,6 +15994,7 @@
               </a:defRPr>
             </a:lvl4pPr>
             <a:lvl5pPr>
+              <a:buNone/>
               <a:defRPr sz="1500" b="0">
                 <a:solidFill>
                   <a:srgbClr val="173B75"/>
@@ -15586,6 +16005,7 @@
               </a:defRPr>
             </a:lvl5pPr>
             <a:lvl6pPr>
+              <a:buNone/>
               <a:defRPr sz="1500" b="0">
                 <a:solidFill>
                   <a:srgbClr val="173B75"/>
@@ -15596,6 +16016,7 @@
               </a:defRPr>
             </a:lvl6pPr>
             <a:lvl7pPr>
+              <a:buNone/>
               <a:defRPr sz="1500" b="0">
                 <a:solidFill>
                   <a:srgbClr val="173B75"/>
@@ -15606,6 +16027,7 @@
               </a:defRPr>
             </a:lvl7pPr>
             <a:lvl8pPr>
+              <a:buNone/>
               <a:defRPr sz="1500" b="0">
                 <a:solidFill>
                   <a:srgbClr val="173B75"/>
@@ -15616,6 +16038,7 @@
               </a:defRPr>
             </a:lvl8pPr>
             <a:lvl9pPr>
+              <a:buNone/>
               <a:defRPr sz="1500" b="0">
                 <a:solidFill>
                   <a:srgbClr val="173B75"/>
@@ -15628,6 +16051,7 @@
           </a:lstStyle>
           <a:p xmlns:a="http://schemas.openxmlformats.org/drawingml/2006/main">
             <a:pPr>
+              <a:buNone/>
               <a:defRPr sz="1500" b="0">
                 <a:solidFill>
                   <a:srgbClr val="173B75"/>
@@ -15651,6 +16075,7 @@
           </a:p>
           <a:p xmlns:a="http://schemas.openxmlformats.org/drawingml/2006/main">
             <a:pPr>
+              <a:buNone/>
               <a:defRPr sz="1500" b="0">
                 <a:solidFill>
                   <a:srgbClr val="173B75"/>
@@ -15751,6 +16176,7 @@
               </a:defRPr>
             </a:defPPr>
             <a:lvl1pPr>
+              <a:buNone/>
               <a:defRPr sz="1575" b="1">
                 <a:solidFill>
                   <a:srgbClr val="1768C7"/>
@@ -15761,6 +16187,7 @@
               </a:defRPr>
             </a:lvl1pPr>
             <a:lvl2pPr>
+              <a:buNone/>
               <a:defRPr sz="1575" b="1">
                 <a:solidFill>
                   <a:srgbClr val="1768C7"/>
@@ -15771,6 +16198,7 @@
               </a:defRPr>
             </a:lvl2pPr>
             <a:lvl3pPr>
+              <a:buNone/>
               <a:defRPr sz="1575" b="1">
                 <a:solidFill>
                   <a:srgbClr val="1768C7"/>
@@ -15781,6 +16209,7 @@
               </a:defRPr>
             </a:lvl3pPr>
             <a:lvl4pPr>
+              <a:buNone/>
               <a:defRPr sz="1575" b="1">
                 <a:solidFill>
                   <a:srgbClr val="1768C7"/>
@@ -15791,6 +16220,7 @@
               </a:defRPr>
             </a:lvl4pPr>
             <a:lvl5pPr>
+              <a:buNone/>
               <a:defRPr sz="1575" b="1">
                 <a:solidFill>
                   <a:srgbClr val="1768C7"/>
@@ -15801,6 +16231,7 @@
               </a:defRPr>
             </a:lvl5pPr>
             <a:lvl6pPr>
+              <a:buNone/>
               <a:defRPr sz="1575" b="1">
                 <a:solidFill>
                   <a:srgbClr val="1768C7"/>
@@ -15811,6 +16242,7 @@
               </a:defRPr>
             </a:lvl6pPr>
             <a:lvl7pPr>
+              <a:buNone/>
               <a:defRPr sz="1575" b="1">
                 <a:solidFill>
                   <a:srgbClr val="1768C7"/>
@@ -15821,6 +16253,7 @@
               </a:defRPr>
             </a:lvl7pPr>
             <a:lvl8pPr>
+              <a:buNone/>
               <a:defRPr sz="1575" b="1">
                 <a:solidFill>
                   <a:srgbClr val="1768C7"/>
@@ -15831,6 +16264,7 @@
               </a:defRPr>
             </a:lvl8pPr>
             <a:lvl9pPr>
+              <a:buNone/>
               <a:defRPr sz="1575" b="1">
                 <a:solidFill>
                   <a:srgbClr val="1768C7"/>
@@ -15843,6 +16277,7 @@
           </a:lstStyle>
           <a:p xmlns:a="http://schemas.openxmlformats.org/drawingml/2006/main">
             <a:pPr>
+              <a:buNone/>
               <a:defRPr sz="1575" b="1">
                 <a:solidFill>
                   <a:srgbClr val="1768C7"/>
@@ -15909,6 +16344,7 @@
               </a:defRPr>
             </a:defPPr>
             <a:lvl1pPr>
+              <a:buNone/>
               <a:defRPr sz="1500" b="0">
                 <a:solidFill>
                   <a:srgbClr val="173B75"/>
@@ -15919,6 +16355,7 @@
               </a:defRPr>
             </a:lvl1pPr>
             <a:lvl2pPr>
+              <a:buNone/>
               <a:defRPr sz="1500" b="0">
                 <a:solidFill>
                   <a:srgbClr val="173B75"/>
@@ -15929,6 +16366,7 @@
               </a:defRPr>
             </a:lvl2pPr>
             <a:lvl3pPr>
+              <a:buNone/>
               <a:defRPr sz="1500" b="0">
                 <a:solidFill>
                   <a:srgbClr val="173B75"/>
@@ -15939,6 +16377,7 @@
               </a:defRPr>
             </a:lvl3pPr>
             <a:lvl4pPr>
+              <a:buNone/>
               <a:defRPr sz="1500" b="0">
                 <a:solidFill>
                   <a:srgbClr val="173B75"/>
@@ -15949,6 +16388,7 @@
               </a:defRPr>
             </a:lvl4pPr>
             <a:lvl5pPr>
+              <a:buNone/>
               <a:defRPr sz="1500" b="0">
                 <a:solidFill>
                   <a:srgbClr val="173B75"/>
@@ -15959,6 +16399,7 @@
               </a:defRPr>
             </a:lvl5pPr>
             <a:lvl6pPr>
+              <a:buNone/>
               <a:defRPr sz="1500" b="0">
                 <a:solidFill>
                   <a:srgbClr val="173B75"/>
@@ -15969,6 +16410,7 @@
               </a:defRPr>
             </a:lvl6pPr>
             <a:lvl7pPr>
+              <a:buNone/>
               <a:defRPr sz="1500" b="0">
                 <a:solidFill>
                   <a:srgbClr val="173B75"/>
@@ -15979,6 +16421,7 @@
               </a:defRPr>
             </a:lvl7pPr>
             <a:lvl8pPr>
+              <a:buNone/>
               <a:defRPr sz="1500" b="0">
                 <a:solidFill>
                   <a:srgbClr val="173B75"/>
@@ -15989,6 +16432,7 @@
               </a:defRPr>
             </a:lvl8pPr>
             <a:lvl9pPr>
+              <a:buNone/>
               <a:defRPr sz="1500" b="0">
                 <a:solidFill>
                   <a:srgbClr val="173B75"/>
@@ -16001,6 +16445,7 @@
           </a:lstStyle>
           <a:p xmlns:a="http://schemas.openxmlformats.org/drawingml/2006/main">
             <a:pPr>
+              <a:buNone/>
               <a:defRPr sz="1500" b="0">
                 <a:solidFill>
                   <a:srgbClr val="173B75"/>
@@ -16024,6 +16469,7 @@
           </a:p>
           <a:p xmlns:a="http://schemas.openxmlformats.org/drawingml/2006/main">
             <a:pPr>
+              <a:buNone/>
               <a:defRPr sz="1500" b="0">
                 <a:solidFill>
                   <a:srgbClr val="173B75"/>
@@ -16124,6 +16570,7 @@
               </a:defRPr>
             </a:defPPr>
             <a:lvl1pPr>
+              <a:buNone/>
               <a:defRPr sz="1575" b="1">
                 <a:solidFill>
                   <a:srgbClr val="1768C7"/>
@@ -16134,6 +16581,7 @@
               </a:defRPr>
             </a:lvl1pPr>
             <a:lvl2pPr>
+              <a:buNone/>
               <a:defRPr sz="1575" b="1">
                 <a:solidFill>
                   <a:srgbClr val="1768C7"/>
@@ -16144,6 +16592,7 @@
               </a:defRPr>
             </a:lvl2pPr>
             <a:lvl3pPr>
+              <a:buNone/>
               <a:defRPr sz="1575" b="1">
                 <a:solidFill>
                   <a:srgbClr val="1768C7"/>
@@ -16154,6 +16603,7 @@
               </a:defRPr>
             </a:lvl3pPr>
             <a:lvl4pPr>
+              <a:buNone/>
               <a:defRPr sz="1575" b="1">
                 <a:solidFill>
                   <a:srgbClr val="1768C7"/>
@@ -16164,6 +16614,7 @@
               </a:defRPr>
             </a:lvl4pPr>
             <a:lvl5pPr>
+              <a:buNone/>
               <a:defRPr sz="1575" b="1">
                 <a:solidFill>
                   <a:srgbClr val="1768C7"/>
@@ -16174,6 +16625,7 @@
               </a:defRPr>
             </a:lvl5pPr>
             <a:lvl6pPr>
+              <a:buNone/>
               <a:defRPr sz="1575" b="1">
                 <a:solidFill>
                   <a:srgbClr val="1768C7"/>
@@ -16184,6 +16636,7 @@
               </a:defRPr>
             </a:lvl6pPr>
             <a:lvl7pPr>
+              <a:buNone/>
               <a:defRPr sz="1575" b="1">
                 <a:solidFill>
                   <a:srgbClr val="1768C7"/>
@@ -16194,6 +16647,7 @@
               </a:defRPr>
             </a:lvl7pPr>
             <a:lvl8pPr>
+              <a:buNone/>
               <a:defRPr sz="1575" b="1">
                 <a:solidFill>
                   <a:srgbClr val="1768C7"/>
@@ -16204,6 +16658,7 @@
               </a:defRPr>
             </a:lvl8pPr>
             <a:lvl9pPr>
+              <a:buNone/>
               <a:defRPr sz="1575" b="1">
                 <a:solidFill>
                   <a:srgbClr val="1768C7"/>
@@ -16216,6 +16671,7 @@
           </a:lstStyle>
           <a:p xmlns:a="http://schemas.openxmlformats.org/drawingml/2006/main">
             <a:pPr>
+              <a:buNone/>
               <a:defRPr sz="1575" b="1">
                 <a:solidFill>
                   <a:srgbClr val="1768C7"/>
@@ -16282,6 +16738,7 @@
               </a:defRPr>
             </a:defPPr>
             <a:lvl1pPr>
+              <a:buNone/>
               <a:defRPr sz="1500" b="0">
                 <a:solidFill>
                   <a:srgbClr val="173B75"/>
@@ -16292,6 +16749,7 @@
               </a:defRPr>
             </a:lvl1pPr>
             <a:lvl2pPr>
+              <a:buNone/>
               <a:defRPr sz="1500" b="0">
                 <a:solidFill>
                   <a:srgbClr val="173B75"/>
@@ -16302,6 +16760,7 @@
               </a:defRPr>
             </a:lvl2pPr>
             <a:lvl3pPr>
+              <a:buNone/>
               <a:defRPr sz="1500" b="0">
                 <a:solidFill>
                   <a:srgbClr val="173B75"/>
@@ -16312,6 +16771,7 @@
               </a:defRPr>
             </a:lvl3pPr>
             <a:lvl4pPr>
+              <a:buNone/>
               <a:defRPr sz="1500" b="0">
                 <a:solidFill>
                   <a:srgbClr val="173B75"/>
@@ -16322,6 +16782,7 @@
               </a:defRPr>
             </a:lvl4pPr>
             <a:lvl5pPr>
+              <a:buNone/>
               <a:defRPr sz="1500" b="0">
                 <a:solidFill>
                   <a:srgbClr val="173B75"/>
@@ -16332,6 +16793,7 @@
               </a:defRPr>
             </a:lvl5pPr>
             <a:lvl6pPr>
+              <a:buNone/>
               <a:defRPr sz="1500" b="0">
                 <a:solidFill>
                   <a:srgbClr val="173B75"/>
@@ -16342,6 +16804,7 @@
               </a:defRPr>
             </a:lvl6pPr>
             <a:lvl7pPr>
+              <a:buNone/>
               <a:defRPr sz="1500" b="0">
                 <a:solidFill>
                   <a:srgbClr val="173B75"/>
@@ -16352,6 +16815,7 @@
               </a:defRPr>
             </a:lvl7pPr>
             <a:lvl8pPr>
+              <a:buNone/>
               <a:defRPr sz="1500" b="0">
                 <a:solidFill>
                   <a:srgbClr val="173B75"/>
@@ -16362,6 +16826,7 @@
               </a:defRPr>
             </a:lvl8pPr>
             <a:lvl9pPr>
+              <a:buNone/>
               <a:defRPr sz="1500" b="0">
                 <a:solidFill>
                   <a:srgbClr val="173B75"/>
@@ -16374,6 +16839,7 @@
           </a:lstStyle>
           <a:p xmlns:a="http://schemas.openxmlformats.org/drawingml/2006/main">
             <a:pPr>
+              <a:buNone/>
               <a:defRPr sz="1500" b="0">
                 <a:solidFill>
                   <a:srgbClr val="173B75"/>
@@ -16397,6 +16863,7 @@
           </a:p>
           <a:p xmlns:a="http://schemas.openxmlformats.org/drawingml/2006/main">
             <a:pPr>
+              <a:buNone/>
               <a:defRPr sz="1500" b="0">
                 <a:solidFill>
                   <a:srgbClr val="173B75"/>
@@ -16463,6 +16930,7 @@
               </a:defRPr>
             </a:defPPr>
             <a:lvl1pPr>
+              <a:buNone/>
               <a:defRPr sz="1650" b="0">
                 <a:solidFill>
                   <a:srgbClr val="607DA3"/>
@@ -16473,6 +16941,7 @@
               </a:defRPr>
             </a:lvl1pPr>
             <a:lvl2pPr>
+              <a:buNone/>
               <a:defRPr sz="1650" b="0">
                 <a:solidFill>
                   <a:srgbClr val="607DA3"/>
@@ -16483,6 +16952,7 @@
               </a:defRPr>
             </a:lvl2pPr>
             <a:lvl3pPr>
+              <a:buNone/>
               <a:defRPr sz="1650" b="0">
                 <a:solidFill>
                   <a:srgbClr val="607DA3"/>
@@ -16493,6 +16963,7 @@
               </a:defRPr>
             </a:lvl3pPr>
             <a:lvl4pPr>
+              <a:buNone/>
               <a:defRPr sz="1650" b="0">
                 <a:solidFill>
                   <a:srgbClr val="607DA3"/>
@@ -16503,6 +16974,7 @@
               </a:defRPr>
             </a:lvl4pPr>
             <a:lvl5pPr>
+              <a:buNone/>
               <a:defRPr sz="1650" b="0">
                 <a:solidFill>
                   <a:srgbClr val="607DA3"/>
@@ -16513,6 +16985,7 @@
               </a:defRPr>
             </a:lvl5pPr>
             <a:lvl6pPr>
+              <a:buNone/>
               <a:defRPr sz="1650" b="0">
                 <a:solidFill>
                   <a:srgbClr val="607DA3"/>
@@ -16523,6 +16996,7 @@
               </a:defRPr>
             </a:lvl6pPr>
             <a:lvl7pPr>
+              <a:buNone/>
               <a:defRPr sz="1650" b="0">
                 <a:solidFill>
                   <a:srgbClr val="607DA3"/>
@@ -16533,6 +17007,7 @@
               </a:defRPr>
             </a:lvl7pPr>
             <a:lvl8pPr>
+              <a:buNone/>
               <a:defRPr sz="1650" b="0">
                 <a:solidFill>
                   <a:srgbClr val="607DA3"/>
@@ -16543,6 +17018,7 @@
               </a:defRPr>
             </a:lvl8pPr>
             <a:lvl9pPr>
+              <a:buNone/>
               <a:defRPr sz="1650" b="0">
                 <a:solidFill>
                   <a:srgbClr val="607DA3"/>
@@ -16555,6 +17031,7 @@
           </a:lstStyle>
           <a:p xmlns:a="http://schemas.openxmlformats.org/drawingml/2006/main">
             <a:pPr>
+              <a:buNone/>
               <a:defRPr sz="1650" b="0">
                 <a:solidFill>
                   <a:srgbClr val="607DA3"/>
@@ -16621,6 +17098,7 @@
               </a:defRPr>
             </a:defPPr>
             <a:lvl1pPr>
+              <a:buNone/>
               <a:defRPr sz="1125" b="0">
                 <a:solidFill>
                   <a:srgbClr val="607DA3"/>
@@ -16631,6 +17109,7 @@
               </a:defRPr>
             </a:lvl1pPr>
             <a:lvl2pPr>
+              <a:buNone/>
               <a:defRPr sz="1125" b="0">
                 <a:solidFill>
                   <a:srgbClr val="607DA3"/>
@@ -16641,6 +17120,7 @@
               </a:defRPr>
             </a:lvl2pPr>
             <a:lvl3pPr>
+              <a:buNone/>
               <a:defRPr sz="1125" b="0">
                 <a:solidFill>
                   <a:srgbClr val="607DA3"/>
@@ -16651,6 +17131,7 @@
               </a:defRPr>
             </a:lvl3pPr>
             <a:lvl4pPr>
+              <a:buNone/>
               <a:defRPr sz="1125" b="0">
                 <a:solidFill>
                   <a:srgbClr val="607DA3"/>
@@ -16661,6 +17142,7 @@
               </a:defRPr>
             </a:lvl4pPr>
             <a:lvl5pPr>
+              <a:buNone/>
               <a:defRPr sz="1125" b="0">
                 <a:solidFill>
                   <a:srgbClr val="607DA3"/>
@@ -16671,6 +17153,7 @@
               </a:defRPr>
             </a:lvl5pPr>
             <a:lvl6pPr>
+              <a:buNone/>
               <a:defRPr sz="1125" b="0">
                 <a:solidFill>
                   <a:srgbClr val="607DA3"/>
@@ -16681,6 +17164,7 @@
               </a:defRPr>
             </a:lvl6pPr>
             <a:lvl7pPr>
+              <a:buNone/>
               <a:defRPr sz="1125" b="0">
                 <a:solidFill>
                   <a:srgbClr val="607DA3"/>
@@ -16691,6 +17175,7 @@
               </a:defRPr>
             </a:lvl7pPr>
             <a:lvl8pPr>
+              <a:buNone/>
               <a:defRPr sz="1125" b="0">
                 <a:solidFill>
                   <a:srgbClr val="607DA3"/>
@@ -16701,6 +17186,7 @@
               </a:defRPr>
             </a:lvl8pPr>
             <a:lvl9pPr>
+              <a:buNone/>
               <a:defRPr sz="1125" b="0">
                 <a:solidFill>
                   <a:srgbClr val="607DA3"/>
@@ -16713,6 +17199,7 @@
           </a:lstStyle>
           <a:p xmlns:a="http://schemas.openxmlformats.org/drawingml/2006/main">
             <a:pPr>
+              <a:buNone/>
               <a:defRPr sz="1125" b="0">
                 <a:solidFill>
                   <a:srgbClr val="607DA3"/>

</xml_diff>